<commit_message>
feat(presentation): update official SIH pitch deck and submission presentation to reflect new front-facing interface
</commit_message>
<xml_diff>
--- a/VayuCoupler_SIH2026_AtomX_Presentation.pptx
+++ b/VayuCoupler_SIH2026_AtomX_Presentation.pptx
@@ -3089,7 +3089,7 @@
     <p:bg>
       <p:bgPr>
         <a:solidFill>
-          <a:srgbClr val="0A1128"/>
+          <a:srgbClr val="0A0B0A"/>
         </a:solidFill>
         <a:effectLst/>
       </p:bgPr>
@@ -3116,11 +3116,11 @@
             <a:avLst/>
           </a:prstGeom>
           <a:solidFill>
-            <a:srgbClr val="131D3A"/>
+            <a:srgbClr val="131513"/>
           </a:solidFill>
           <a:ln w="15240">
             <a:solidFill>
-              <a:srgbClr val="00E5FF"/>
+              <a:srgbClr val="8FFFB0"/>
             </a:solidFill>
           </a:ln>
         </p:spPr>
@@ -3171,7 +3171,7 @@
             <a:pPr>
               <a:defRPr sz="1100" b="1">
                 <a:solidFill>
-                  <a:srgbClr val="00E5FF"/>
+                  <a:srgbClr val="8FFFB0"/>
                 </a:solidFill>
                 <a:latin typeface="Calibri"/>
               </a:defRPr>
@@ -3243,13 +3243,13 @@
             <a:pPr>
               <a:defRPr sz="1500" b="1">
                 <a:solidFill>
-                  <a:srgbClr val="38BDF8"/>
+                  <a:srgbClr val="7FD4FF"/>
                 </a:solidFill>
                 <a:latin typeface="Calibri"/>
               </a:defRPr>
             </a:pPr>
             <a:r>
-              <a:t>Air Pollution–Weather Coupled Forecasting &amp; Predictive GRAP Decision Support System</a:t>
+              <a:t>Next-Generation Air Pollution–Weather Coupled Atmospheric Cockpit (Delhi-NCR Focus)</a:t>
             </a:r>
           </a:p>
         </p:txBody>
@@ -3269,11 +3269,11 @@
             <a:avLst/>
           </a:prstGeom>
           <a:solidFill>
-            <a:srgbClr val="0F172A"/>
+            <a:srgbClr val="191C19"/>
           </a:solidFill>
           <a:ln w="15240">
             <a:solidFill>
-              <a:srgbClr val="26385F"/>
+              <a:srgbClr val="262A26"/>
             </a:solidFill>
           </a:ln>
         </p:spPr>
@@ -3336,7 +3336,7 @@
             <a:pPr>
               <a:defRPr sz="950">
                 <a:solidFill>
-                  <a:srgbClr val="E2E8F0"/>
+                  <a:srgbClr val="EEF0EC"/>
                 </a:solidFill>
               </a:defRPr>
             </a:pPr>
@@ -3345,7 +3345,7 @@
             </a:r>
             <a:br/>
             <a:r>
-              <a:t>• Title: Air Pollution–Weather Coupled Forecasting (Delhi NCR Focus)</a:t>
+              <a:t>• Title: Air Pollution–Weather Coupled Forecasting System (Delhi NCR Focus)</a:t>
             </a:r>
             <a:br/>
             <a:r>
@@ -3353,7 +3353,7 @@
             </a:r>
             <a:br/>
             <a:r>
-              <a:t>• Nodal Alignment: CAQM, CPCB, IMD</a:t>
+              <a:t>• Nodal Stakeholders: CAQM, CPCB, IMD</a:t>
             </a:r>
           </a:p>
         </p:txBody>
@@ -3373,11 +3373,11 @@
             <a:avLst/>
           </a:prstGeom>
           <a:solidFill>
-            <a:srgbClr val="0F172A"/>
+            <a:srgbClr val="191C19"/>
           </a:solidFill>
           <a:ln w="15240">
             <a:solidFill>
-              <a:srgbClr val="26385F"/>
+              <a:srgbClr val="262A26"/>
             </a:solidFill>
           </a:ln>
         </p:spPr>
@@ -3428,40 +3428,40 @@
             <a:pPr>
               <a:defRPr b="1" sz="1000">
                 <a:solidFill>
-                  <a:srgbClr val="F59E0B"/>
-                </a:solidFill>
-              </a:defRPr>
-            </a:pPr>
-            <a:r>
-              <a:t>CORE VALUE PROPOSITION</a:t>
+                  <a:srgbClr val="FFE270"/>
+                </a:solidFill>
+              </a:defRPr>
+            </a:pPr>
+            <a:r>
+              <a:t>CORE FRONT-FACING PILLARS</a:t>
             </a:r>
           </a:p>
           <a:p>
             <a:pPr>
               <a:defRPr sz="950">
                 <a:solidFill>
-                  <a:srgbClr val="E2E8F0"/>
-                </a:solidFill>
-              </a:defRPr>
-            </a:pPr>
-            <a:r>
-              <a:t>• 48h to 72h Pre-emptive Lead Time</a:t>
+                  <a:srgbClr val="EEF0EC"/>
+                </a:solidFill>
+              </a:defRPr>
+            </a:pPr>
+            <a:r>
+              <a:t>• Atmospheric Home Cockpit &amp; Ambient Halo</a:t>
             </a:r>
             <a:br/>
             <a:r>
-              <a:t>• Dynamic PBLH &amp; Inversion Coupling</a:t>
+              <a:t>• Google Weather-Style Microclimate Engine</a:t>
             </a:r>
             <a:br/>
             <a:r>
-              <a:t>• NASA FIRMS Stubble Plume Vectoring</a:t>
+              <a:t>• 40+ Station Interactive GIS Spatial Map</a:t>
             </a:r>
             <a:br/>
             <a:r>
-              <a:t>• Closed-loop Multi-Agency Dispatch</a:t>
+              <a:t>• Safe Commute Cleanest-Route Navigator</a:t>
             </a:r>
             <a:br/>
             <a:r>
-              <a:t>• 'What-If' Counterfactual Policy Simulator</a:t>
+              <a:t>• Conversational VayuAI Atmospheric Copilot</a:t>
             </a:r>
           </a:p>
         </p:txBody>
@@ -3481,11 +3481,11 @@
             <a:avLst/>
           </a:prstGeom>
           <a:solidFill>
-            <a:srgbClr val="0F172A"/>
+            <a:srgbClr val="191C19"/>
           </a:solidFill>
           <a:ln w="15240">
             <a:solidFill>
-              <a:srgbClr val="26385F"/>
+              <a:srgbClr val="262A26"/>
             </a:solidFill>
           </a:ln>
         </p:spPr>
@@ -3536,7 +3536,7 @@
             <a:pPr>
               <a:defRPr b="1" sz="1000">
                 <a:solidFill>
-                  <a:srgbClr val="10B981"/>
+                  <a:srgbClr val="8FFFB0"/>
                 </a:solidFill>
               </a:defRPr>
             </a:pPr>
@@ -3548,12 +3548,12 @@
             <a:pPr>
               <a:defRPr sz="950">
                 <a:solidFill>
-                  <a:srgbClr val="E2E8F0"/>
-                </a:solidFill>
-              </a:defRPr>
-            </a:pPr>
-            <a:r>
-              <a:t>• Live Web: https://vayucoupler.vercel.app</a:t>
+                  <a:srgbClr val="EEF0EC"/>
+                </a:solidFill>
+              </a:defRPr>
+            </a:pPr>
+            <a:r>
+              <a:t>• Live Web Cockpit: https://vayucoupler.vercel.app</a:t>
             </a:r>
             <a:br/>
             <a:r>
@@ -3565,7 +3565,7 @@
             </a:r>
             <a:br/>
             <a:r>
-              <a:t>• Android Native APK: 5.4MB with offline caching</a:t>
+              <a:t>• Standalone Mobile App: Phone-first UI &amp; offline caching</a:t>
             </a:r>
           </a:p>
         </p:txBody>
@@ -3595,7 +3595,7 @@
             <a:pPr>
               <a:defRPr b="1" sz="1050">
                 <a:solidFill>
-                  <a:srgbClr val="00E5FF"/>
+                  <a:srgbClr val="8FFFB0"/>
                 </a:solidFill>
               </a:defRPr>
             </a:pPr>
@@ -3610,20 +3610,20 @@
               </a:spcBef>
               <a:defRPr sz="950">
                 <a:solidFill>
-                  <a:srgbClr val="E2E8F0"/>
-                </a:solidFill>
-              </a:defRPr>
-            </a:pPr>
-            <a:r>
-              <a:t>• Vivek Raj (Team Lead — Systems Architecture, Coupled Physics &amp; Geospatial Engine)   • Member 2 (PBLH &amp; Inversion Modeling)</a:t>
+                  <a:srgbClr val="EEF0EC"/>
+                </a:solidFill>
+              </a:defRPr>
+            </a:pPr>
+            <a:r>
+              <a:t>• Vivek Raj (Team Lead — Systems Architecture, Atmospheric Coupling &amp; Cockpit Design)   • Member 2 (Google Weather Engine &amp; Microclimate Physics)</a:t>
             </a:r>
             <a:br/>
             <a:r>
-              <a:t>• Member 3 (Backend Telemetry &amp; Multi-Agency Dispatch Architecture)   • Member 4 (Geospatial UI/UX, Particle Wind Flow &amp; Visuals)</a:t>
+              <a:t>• Member 3 (Safe Commute Exposure Routing &amp; Geospatial GIS Engine)   • Member 4 (Ambient Halo UI/UX &amp; Responsive Front-End Systems)</a:t>
             </a:r>
             <a:br/>
             <a:r>
-              <a:t>• Member 5 (ML Forecaster &amp; Source Attribution Engine)   • Member 6 (Cross-Platform Mobile Android &amp; Windows Offline Packaging)</a:t>
+              <a:t>• Member 5 (VayuAI LLM Grounding &amp; Environmental Data Pipeline)   • Member 6 (Windows Standalone Offline Packaging &amp; Mobile Architecture)</a:t>
             </a:r>
           </a:p>
         </p:txBody>
@@ -3653,7 +3653,7 @@
             <a:pPr>
               <a:defRPr sz="850" b="1">
                 <a:solidFill>
-                  <a:srgbClr val="94A3B8"/>
+                  <a:srgbClr val="8C948B"/>
                 </a:solidFill>
                 <a:latin typeface="Calibri"/>
               </a:defRPr>
@@ -3666,7 +3666,7 @@
             <a:pPr algn="r">
               <a:defRPr sz="850">
                 <a:solidFill>
-                  <a:srgbClr val="00E5FF"/>
+                  <a:srgbClr val="8FFFB0"/>
                 </a:solidFill>
                 <a:latin typeface="Calibri"/>
               </a:defRPr>
@@ -3691,7 +3691,7 @@
     <p:bg>
       <p:bgPr>
         <a:solidFill>
-          <a:srgbClr val="0A1128"/>
+          <a:srgbClr val="0A0B0A"/>
         </a:solidFill>
         <a:effectLst/>
       </p:bgPr>
@@ -3728,13 +3728,13 @@
             <a:pPr>
               <a:defRPr sz="950" b="1">
                 <a:solidFill>
-                  <a:srgbClr val="00E5FF"/>
+                  <a:srgbClr val="8FFFB0"/>
                 </a:solidFill>
                 <a:latin typeface="Calibri"/>
               </a:defRPr>
             </a:pPr>
             <a:r>
-              <a:t>SIH26082 | CURRENT EMERGENCY CONTEXT</a:t>
+              <a:t>SIH26082 | ENVIRONMENTAL EMERGENCY &amp; INTERFACE GAP</a:t>
             </a:r>
           </a:p>
         </p:txBody>
@@ -3770,7 +3770,7 @@
               </a:defRPr>
             </a:pPr>
             <a:r>
-              <a:t>The Problem: Delhi's Smog Trap &amp; The Fatal Flaw of Reactive GRAP</a:t>
+              <a:t>The Challenge: Complex Atmospheric Data vs. Citizen Usability</a:t>
             </a:r>
           </a:p>
         </p:txBody>
@@ -3800,13 +3800,13 @@
             <a:pPr>
               <a:defRPr sz="1150">
                 <a:solidFill>
-                  <a:srgbClr val="94A3B8"/>
+                  <a:srgbClr val="8C948B"/>
                 </a:solidFill>
                 <a:latin typeface="Calibri"/>
               </a:defRPr>
             </a:pPr>
             <a:r>
-              <a:t>Every winter, 30 million citizens choke because existing emergency systems enforce curbs only after the crisis arrives.</a:t>
+              <a:t>Solving Delhi-NCR's air quality crisis requires replacing cluttered legacy portals with an intuitive, action-driven front cockpit.</a:t>
             </a:r>
           </a:p>
         </p:txBody>
@@ -3826,7 +3826,7 @@
             <a:avLst/>
           </a:prstGeom>
           <a:solidFill>
-            <a:srgbClr val="131D3A"/>
+            <a:srgbClr val="131513"/>
           </a:solidFill>
           <a:ln w="15240">
             <a:solidFill>
@@ -3886,7 +3886,7 @@
               </a:defRPr>
             </a:pPr>
             <a:r>
-              <a:t>🚨 FATAL FLAW OF REACTIVE GRAP</a:t>
+              <a:t>🚨 FLAWS OF LEGACY AIR PORTALS</a:t>
             </a:r>
           </a:p>
           <a:p>
@@ -3896,12 +3896,12 @@
               </a:spcBef>
               <a:defRPr sz="950">
                 <a:solidFill>
-                  <a:srgbClr val="E2E8F0"/>
-                </a:solidFill>
-              </a:defRPr>
-            </a:pPr>
-            <a:r>
-              <a:t>• Post-Facto Trigger Rule: CAQM/CPCB Stage III &amp; IV emergency curbs (halting construction, halting interstate trucks) are triggered ONLY AFTER ground stations record 'Severe' (400+) for 48 consecutive hours.</a:t>
+                  <a:srgbClr val="EEF0EC"/>
+                </a:solidFill>
+              </a:defRPr>
+            </a:pPr>
+            <a:r>
+              <a:t>• Disconnected Meteorology: Citizens &amp; officials check AQI on one app and weather on another, missing the direct physical link between wind/humidity and smog trapping.</a:t>
             </a:r>
           </a:p>
           <a:p>
@@ -3911,12 +3911,12 @@
               </a:spcBef>
               <a:defRPr sz="950">
                 <a:solidFill>
-                  <a:srgbClr val="E2E8F0"/>
-                </a:solidFill>
-              </a:defRPr>
-            </a:pPr>
-            <a:r>
-              <a:t>• Zero Lead Time: By the time diesel trucks or construction are banned, the dense smog trap has already formed over Delhi.</a:t>
+                  <a:srgbClr val="EEF0EC"/>
+                </a:solidFill>
+              </a:defRPr>
+            </a:pPr>
+            <a:r>
+              <a:t>• Inactionable Data Dumps: Existing portals display complex, static PDF tables and technical jargon that non-specialists cannot parse in an emergency.</a:t>
             </a:r>
           </a:p>
           <a:p>
@@ -3926,12 +3926,12 @@
               </a:spcBef>
               <a:defRPr sz="950">
                 <a:solidFill>
-                  <a:srgbClr val="E2E8F0"/>
-                </a:solidFill>
-              </a:defRPr>
-            </a:pPr>
-            <a:r>
-              <a:t>• Irreversible Health Harm: Children, asthmatics, and seniors inhale toxic particulate matter for 2 to 3 days before authorities react.</a:t>
+                  <a:srgbClr val="EEF0EC"/>
+                </a:solidFill>
+              </a:defRPr>
+            </a:pPr>
+            <a:r>
+              <a:t>• Passive Exposure Maps: Legacy maps place static red dots on stations without offering any practical guidance on how to avoid inhaling toxic particulate matter.</a:t>
             </a:r>
           </a:p>
           <a:p>
@@ -3941,12 +3941,12 @@
               </a:spcBef>
               <a:defRPr sz="950">
                 <a:solidFill>
-                  <a:srgbClr val="E2E8F0"/>
-                </a:solidFill>
-              </a:defRPr>
-            </a:pPr>
-            <a:r>
-              <a:t>• Economic Shock: Sudden overnight blanket bans leave daily-wage workers stranded without preventing the initial spike.</a:t>
+                  <a:srgbClr val="EEF0EC"/>
+                </a:solidFill>
+              </a:defRPr>
+            </a:pPr>
+            <a:r>
+              <a:t>• Zero Conversational Access: Ordinary citizens have no way to ask everyday questions like 'Is it safe for a morning run?' without deciphering raw PM2.5 values.</a:t>
             </a:r>
           </a:p>
         </p:txBody>
@@ -3966,11 +3966,11 @@
             <a:avLst/>
           </a:prstGeom>
           <a:solidFill>
-            <a:srgbClr val="131D3A"/>
+            <a:srgbClr val="131513"/>
           </a:solidFill>
           <a:ln w="15240">
             <a:solidFill>
-              <a:srgbClr val="F59E0B"/>
+              <a:srgbClr val="FFE270"/>
             </a:solidFill>
           </a:ln>
         </p:spPr>
@@ -4021,12 +4021,12 @@
             <a:pPr>
               <a:defRPr b="1" sz="1200">
                 <a:solidFill>
-                  <a:srgbClr val="F59E0B"/>
-                </a:solidFill>
-              </a:defRPr>
-            </a:pPr>
-            <a:r>
-              <a:t>🔬 DISCONNECTED METEOROLOGY</a:t>
+                  <a:srgbClr val="FFE270"/>
+                </a:solidFill>
+              </a:defRPr>
+            </a:pPr>
+            <a:r>
+              <a:t>💡 THE UNIFIED ATMOSPHERIC COCKPIT</a:t>
             </a:r>
           </a:p>
           <a:p>
@@ -4036,12 +4036,12 @@
               </a:spcBef>
               <a:defRPr sz="950">
                 <a:solidFill>
-                  <a:srgbClr val="E2E8F0"/>
-                </a:solidFill>
-              </a:defRPr>
-            </a:pPr>
-            <a:r>
-              <a:t>• Trapping Crisis: Delhi's air crisis is fundamentally an atmospheric physics problem, not merely an emission issue.</a:t>
+                  <a:srgbClr val="EEF0EC"/>
+                </a:solidFill>
+              </a:defRPr>
+            </a:pPr>
+            <a:r>
+              <a:t>• Phone-First Modern Design: Built with fluid responsive layouts, natural glassmorphism, and a luminous dark command-center aesthetic (#0A0B0A).</a:t>
             </a:r>
           </a:p>
           <a:p>
@@ -4051,12 +4051,12 @@
               </a:spcBef>
               <a:defRPr sz="950">
                 <a:solidFill>
-                  <a:srgbClr val="E2E8F0"/>
-                </a:solidFill>
-              </a:defRPr>
-            </a:pPr>
-            <a:r>
-              <a:t>• Boundary Layer Compression: Planetary Boundary Layer Height (PBLH) collapses from 1,800m in daytime to under 350m at night.</a:t>
+                  <a:srgbClr val="EEF0EC"/>
+                </a:solidFill>
+              </a:defRPr>
+            </a:pPr>
+            <a:r>
+              <a:t>• Ambient Halo AQI Visualizer: Instant situational clarity via dynamic glowing radial halo rings that pulse in category-specific HSL tones.</a:t>
             </a:r>
           </a:p>
           <a:p>
@@ -4066,12 +4066,12 @@
               </a:spcBef>
               <a:defRPr sz="950">
                 <a:solidFill>
-                  <a:srgbClr val="E2E8F0"/>
-                </a:solidFill>
-              </a:defRPr>
-            </a:pPr>
-            <a:r>
-              <a:t>• Thermal Inversion Lid: Colder surface air trapped under warm aloft air prevents vertical dispersion (ΔT &gt; 4°C).</a:t>
+                  <a:srgbClr val="EEF0EC"/>
+                </a:solidFill>
+              </a:defRPr>
+            </a:pPr>
+            <a:r>
+              <a:t>• Deep Meteorological Coupling: Full Google Weather-style atmospheric engine directly embedded beside air quality telemetry.</a:t>
             </a:r>
           </a:p>
           <a:p>
@@ -4081,12 +4081,12 @@
               </a:spcBef>
               <a:defRPr sz="950">
                 <a:solidFill>
-                  <a:srgbClr val="E2E8F0"/>
-                </a:solidFill>
-              </a:defRPr>
-            </a:pPr>
-            <a:r>
-              <a:t>• Legacy Black-Box Flaw: Existing models treat AQI as an isolated statistical curve, ignoring real-time atmospheric dynamics.</a:t>
+                  <a:srgbClr val="EEF0EC"/>
+                </a:solidFill>
+              </a:defRPr>
+            </a:pPr>
+            <a:r>
+              <a:t>• Active Exposure Reduction: Shifts the paradigm from passive monitoring to actionable personal protection with Clean-Path Commute routing.</a:t>
             </a:r>
           </a:p>
         </p:txBody>
@@ -4106,11 +4106,11 @@
             <a:avLst/>
           </a:prstGeom>
           <a:solidFill>
-            <a:srgbClr val="131D3A"/>
+            <a:srgbClr val="131513"/>
           </a:solidFill>
           <a:ln w="15240">
             <a:solidFill>
-              <a:srgbClr val="38BDF8"/>
+              <a:srgbClr val="8FFFB0"/>
             </a:solidFill>
           </a:ln>
         </p:spPr>
@@ -4161,12 +4161,12 @@
             <a:pPr>
               <a:defRPr b="1" sz="1200">
                 <a:solidFill>
-                  <a:srgbClr val="38BDF8"/>
-                </a:solidFill>
-              </a:defRPr>
-            </a:pPr>
-            <a:r>
-              <a:t>🏛️ TRANS-BOUNDARY SILOS</a:t>
+                  <a:srgbClr val="8FFFB0"/>
+                </a:solidFill>
+              </a:defRPr>
+            </a:pPr>
+            <a:r>
+              <a:t>📱 5 CORE FRONT-FACING PILLARS</a:t>
             </a:r>
           </a:p>
           <a:p>
@@ -4176,12 +4176,12 @@
               </a:spcBef>
               <a:defRPr sz="950">
                 <a:solidFill>
-                  <a:srgbClr val="E2E8F0"/>
-                </a:solidFill>
-              </a:defRPr>
-            </a:pPr>
-            <a:r>
-              <a:t>• Trans-Boundary Influx: 30% to 45% of peak winter PM2.5 in Delhi arrives via trans-boundary transport from Punjab &amp; Haryana stubble burning.</a:t>
+                  <a:srgbClr val="EEF0EC"/>
+                </a:solidFill>
+              </a:defRPr>
+            </a:pPr>
+            <a:r>
+              <a:t>• 1. 🏠 Home Cockpit: Huge live AQI, ambient halo ring, nearest station indicator, dynamic health advisory &amp; 3-Day Forecast strip.</a:t>
             </a:r>
           </a:p>
           <a:p>
@@ -4191,12 +4191,12 @@
               </a:spcBef>
               <a:defRPr sz="950">
                 <a:solidFill>
-                  <a:srgbClr val="E2E8F0"/>
-                </a:solidFill>
-              </a:defRPr>
-            </a:pPr>
-            <a:r>
-              <a:t>• Inter-State Blame Game: Delhi declares red alert while upwind states continue burning due to lack of synchronized early warnings.</a:t>
+                  <a:srgbClr val="EEF0EC"/>
+                </a:solidFill>
+              </a:defRPr>
+            </a:pPr>
+            <a:r>
+              <a:t>• 2. 🌤️ Weather Engine: Real-time temp (°C/°F), conditions, 4 microclimate cards (Rain %, Wind km/h, Humidity %, UV), 8-day outlook &amp; hourly scrubber.</a:t>
             </a:r>
           </a:p>
           <a:p>
@@ -4206,12 +4206,12 @@
               </a:spcBef>
               <a:defRPr sz="950">
                 <a:solidFill>
-                  <a:srgbClr val="E2E8F0"/>
-                </a:solidFill>
-              </a:defRPr>
-            </a:pPr>
-            <a:r>
-              <a:t>• No 'What-If' Capability: Current portals display static graphs; policymakers cannot simulate policy impacts before enforcing curbs.</a:t>
+                  <a:srgbClr val="EEF0EC"/>
+                </a:solidFill>
+              </a:defRPr>
+            </a:pPr>
+            <a:r>
+              <a:t>• 3. 🗺️ Map &amp; Data: Interactive 40+ station GIS grid with 6-pollutant telemetry (PM2.5, PM10, NO2, SO2, CO, O3) and spatial heatmap.</a:t>
             </a:r>
           </a:p>
           <a:p>
@@ -4221,12 +4221,27 @@
               </a:spcBef>
               <a:defRPr sz="950">
                 <a:solidFill>
-                  <a:srgbClr val="E2E8F0"/>
-                </a:solidFill>
-              </a:defRPr>
-            </a:pPr>
-            <a:r>
-              <a:t>• No Role-Based Dispatch: Agencies receive generic PDFs instead of automated, legally binding executive work orders.</a:t>
+                  <a:srgbClr val="EEF0EC"/>
+                </a:solidFill>
+              </a:defRPr>
+            </a:pPr>
+            <a:r>
+              <a:t>• 4. 🧭 Safe Commute: Intelligent route finder comparing Fastest vs. Cleanest path, cutting toxic inhaled dosage by 35%–48%.</a:t>
+            </a:r>
+          </a:p>
+          <a:p>
+            <a:pPr>
+              <a:spcBef>
+                <a:spcPts val="600"/>
+              </a:spcBef>
+              <a:defRPr sz="950">
+                <a:solidFill>
+                  <a:srgbClr val="EEF0EC"/>
+                </a:solidFill>
+              </a:defRPr>
+            </a:pPr>
+            <a:r>
+              <a:t>• 5. 🤖 VayuAI Assistant: Domain-grounded conversational copilot for instant natural language health and activity decisions.</a:t>
             </a:r>
           </a:p>
         </p:txBody>
@@ -4256,7 +4271,7 @@
             <a:pPr>
               <a:defRPr sz="850" b="1">
                 <a:solidFill>
-                  <a:srgbClr val="94A3B8"/>
+                  <a:srgbClr val="8C948B"/>
                 </a:solidFill>
                 <a:latin typeface="Calibri"/>
               </a:defRPr>
@@ -4269,7 +4284,7 @@
             <a:pPr algn="r">
               <a:defRPr sz="850">
                 <a:solidFill>
-                  <a:srgbClr val="00E5FF"/>
+                  <a:srgbClr val="8FFFB0"/>
                 </a:solidFill>
                 <a:latin typeface="Calibri"/>
               </a:defRPr>
@@ -4294,7 +4309,7 @@
     <p:bg>
       <p:bgPr>
         <a:solidFill>
-          <a:srgbClr val="0A1128"/>
+          <a:srgbClr val="0A0B0A"/>
         </a:solidFill>
         <a:effectLst/>
       </p:bgPr>
@@ -4331,13 +4346,13 @@
             <a:pPr>
               <a:defRPr sz="950" b="1">
                 <a:solidFill>
-                  <a:srgbClr val="00E5FF"/>
+                  <a:srgbClr val="8FFFB0"/>
                 </a:solidFill>
                 <a:latin typeface="Calibri"/>
               </a:defRPr>
             </a:pPr>
             <a:r>
-              <a:t>SIH26082 | SCIENTIFIC &amp; MATHEMATICAL INNOVATION</a:t>
+              <a:t>SIH26082 | CORE FRONT INTERFACE ARCHITECTURE</a:t>
             </a:r>
           </a:p>
         </p:txBody>
@@ -4373,7 +4388,7 @@
               </a:defRPr>
             </a:pPr>
             <a:r>
-              <a:t>Our Solution: Predictive GRAP Grounded in Atmospheric Physics</a:t>
+              <a:t>Front Pillar 1 &amp; 2: Atmospheric Home Cockpit &amp; Live Weather Engine</a:t>
             </a:r>
           </a:p>
         </p:txBody>
@@ -4403,13 +4418,13 @@
             <a:pPr>
               <a:defRPr sz="1150">
                 <a:solidFill>
-                  <a:srgbClr val="94A3B8"/>
+                  <a:srgbClr val="8C948B"/>
                 </a:solidFill>
                 <a:latin typeface="Calibri"/>
               </a:defRPr>
             </a:pPr>
             <a:r>
-              <a:t>Zero black-box obscurity — coupling boundary layer compression with satellite fire telemetry for 48h–72h lead time.</a:t>
+              <a:t>Instant ambient visual clarity combined with Google Weather-style atmospheric microclimate dynamics.</a:t>
             </a:r>
           </a:p>
         </p:txBody>
@@ -4423,17 +4438,17 @@
         <p:spPr>
           <a:xfrm>
             <a:off x="731520" y="1508760"/>
-            <a:ext cx="10728655" cy="822960"/>
+            <a:ext cx="5230368" cy="4663440"/>
           </a:xfrm>
           <a:prstGeom prst="roundRect">
             <a:avLst/>
           </a:prstGeom>
           <a:solidFill>
-            <a:srgbClr val="131D3A"/>
+            <a:srgbClr val="191C19"/>
           </a:solidFill>
           <a:ln w="15240">
             <a:solidFill>
-              <a:srgbClr val="00E5FF"/>
+              <a:srgbClr val="8FFFB0"/>
             </a:solidFill>
           </a:ln>
         </p:spPr>
@@ -4467,8 +4482,8 @@
         </p:nvSpPr>
         <p:spPr>
           <a:xfrm>
-            <a:off x="914400" y="1572768"/>
-            <a:ext cx="10362895" cy="685800"/>
+            <a:off x="914400" y="1645920"/>
+            <a:ext cx="4864608" cy="4389120"/>
           </a:xfrm>
           <a:prstGeom prst="rect">
             <a:avLst/>
@@ -4484,27 +4499,120 @@
             <a:pPr>
               <a:defRPr b="1" sz="1200">
                 <a:solidFill>
-                  <a:srgbClr val="00E5FF"/>
-                </a:solidFill>
-              </a:defRPr>
-            </a:pPr>
-            <a:r>
-              <a:t>THE PARADIGM SHIFT: REACTIVE GRAP  ➜  PREDICTIVE GRAP (48h–72h LEAD TIME)</a:t>
+                  <a:srgbClr val="8FFFB0"/>
+                </a:solidFill>
+              </a:defRPr>
+            </a:pPr>
+            <a:r>
+              <a:t>🏠 PILLAR 1: ATMOSPHERIC HOME COCKPIT</a:t>
             </a:r>
           </a:p>
           <a:p>
             <a:pPr>
               <a:spcBef>
-                <a:spcPts val="100"/>
+                <a:spcPts val="600"/>
               </a:spcBef>
-              <a:defRPr sz="1000">
+              <a:defRPr b="1" sz="950">
                 <a:solidFill>
                   <a:srgbClr val="FFFFFF"/>
                 </a:solidFill>
               </a:defRPr>
             </a:pPr>
             <a:r>
-              <a:t>Instead of waiting for stations to record 400+ AQI, VayuCoupler calculates boundary layer collapse and upwind stubble transport to trigger Stage II, III, and IV curbs 48 to 72 hours BEFORE the critical pollution peak arrives.</a:t>
+              <a:t>• Atmospheric Ambient Halo AQI Meter:</a:t>
+            </a:r>
+          </a:p>
+          <a:p>
+            <a:pPr>
+              <a:defRPr sz="900">
+                <a:solidFill>
+                  <a:srgbClr val="EEF0EC"/>
+                </a:solidFill>
+              </a:defRPr>
+            </a:pPr>
+            <a:r>
+              <a:t>   A massive live AQI reading (e.g., 157 Moderate / 312 Very Poor) enveloped by glowing multi-ring radial halos pulsing in real-time color tiers (Green, Blue, Yellow, Orange, Red, Severe Maroon).</a:t>
+            </a:r>
+          </a:p>
+          <a:p>
+            <a:pPr>
+              <a:spcBef>
+                <a:spcPts val="600"/>
+              </a:spcBef>
+              <a:defRPr b="1" sz="950">
+                <a:solidFill>
+                  <a:srgbClr val="FFFFFF"/>
+                </a:solidFill>
+              </a:defRPr>
+            </a:pPr>
+            <a:r>
+              <a:t>• Live Monitoring Station Selector:</a:t>
+            </a:r>
+          </a:p>
+          <a:p>
+            <a:pPr>
+              <a:defRPr sz="900">
+                <a:solidFill>
+                  <a:srgbClr val="EEF0EC"/>
+                </a:solidFill>
+              </a:defRPr>
+            </a:pPr>
+            <a:r>
+              <a:t>   Instant one-tap modal to switch between 40+ DPCC &amp; CPCB CAAQMS stations (Punjabi Bagh, Anand Vihar, IGI T3, RK Puram) with GPS proximity auto-detection.</a:t>
+            </a:r>
+          </a:p>
+          <a:p>
+            <a:pPr>
+              <a:spcBef>
+                <a:spcPts val="600"/>
+              </a:spcBef>
+              <a:defRPr b="1" sz="950">
+                <a:solidFill>
+                  <a:srgbClr val="FFFFFF"/>
+                </a:solidFill>
+              </a:defRPr>
+            </a:pPr>
+            <a:r>
+              <a:t>• Categorical Severity Pill &amp; Actionable Advisory:</a:t>
+            </a:r>
+          </a:p>
+          <a:p>
+            <a:pPr>
+              <a:defRPr sz="900">
+                <a:solidFill>
+                  <a:srgbClr val="EEF0EC"/>
+                </a:solidFill>
+              </a:defRPr>
+            </a:pPr>
+            <a:r>
+              <a:t>   Dynamic color-coded status badge paired with clear, single-line medical and outdoor guidance tailored to the active station's exposure tier.</a:t>
+            </a:r>
+          </a:p>
+          <a:p>
+            <a:pPr>
+              <a:spcBef>
+                <a:spcPts val="600"/>
+              </a:spcBef>
+              <a:defRPr b="1" sz="950">
+                <a:solidFill>
+                  <a:srgbClr val="FFFFFF"/>
+                </a:solidFill>
+              </a:defRPr>
+            </a:pPr>
+            <a:r>
+              <a:t>• Coupled 3-Day Forecast Strip:</a:t>
+            </a:r>
+          </a:p>
+          <a:p>
+            <a:pPr>
+              <a:defRPr sz="900">
+                <a:solidFill>
+                  <a:srgbClr val="EEF0EC"/>
+                </a:solidFill>
+              </a:defRPr>
+            </a:pPr>
+            <a:r>
+              <a:t>   Continuous 72-hour air quality forecast cards displaying Tomorrow (+24h), Day After (+48h), and Day 3 (+72h) projections with categorical tags and atmospheric trend indicators.</a:t>
             </a:r>
           </a:p>
         </p:txBody>
@@ -4517,18 +4625,18 @@
         </p:nvSpPr>
         <p:spPr>
           <a:xfrm>
-            <a:off x="731520" y="2423160"/>
-            <a:ext cx="5230368" cy="1874519"/>
+            <a:off x="6229807" y="1508760"/>
+            <a:ext cx="5230368" cy="4663440"/>
           </a:xfrm>
           <a:prstGeom prst="roundRect">
             <a:avLst/>
           </a:prstGeom>
           <a:solidFill>
-            <a:srgbClr val="0F172A"/>
+            <a:srgbClr val="191C19"/>
           </a:solidFill>
           <a:ln w="15240">
             <a:solidFill>
-              <a:srgbClr val="00E5FF"/>
+              <a:srgbClr val="FFE270"/>
             </a:solidFill>
           </a:ln>
         </p:spPr>
@@ -4562,8 +4670,8 @@
         </p:nvSpPr>
         <p:spPr>
           <a:xfrm>
-            <a:off x="868680" y="2514600"/>
-            <a:ext cx="4956048" cy="1691639"/>
+            <a:off x="6412687" y="1645920"/>
+            <a:ext cx="4864608" cy="4389120"/>
           </a:xfrm>
           <a:prstGeom prst="rect">
             <a:avLst/>
@@ -4577,76 +4685,345 @@
           <a:lstStyle/>
           <a:p>
             <a:pPr>
-              <a:defRPr b="1" sz="1100">
-                <a:solidFill>
-                  <a:srgbClr val="00E5FF"/>
-                </a:solidFill>
-              </a:defRPr>
-            </a:pPr>
-            <a:r>
-              <a:t>1. VENTILATION INDEX (VI) — FLUSHING CAPACITY</a:t>
+              <a:defRPr b="1" sz="1200">
+                <a:solidFill>
+                  <a:srgbClr val="FFE270"/>
+                </a:solidFill>
+              </a:defRPr>
+            </a:pPr>
+            <a:r>
+              <a:t>🌤️ PILLAR 2: GOOGLE WEATHER-STYLE LIVE ENGINE</a:t>
             </a:r>
           </a:p>
           <a:p>
             <a:pPr>
               <a:spcBef>
-                <a:spcPts val="300"/>
+                <a:spcPts val="600"/>
               </a:spcBef>
-              <a:defRPr b="1" sz="1200">
+              <a:defRPr b="1" sz="950">
                 <a:solidFill>
                   <a:srgbClr val="FFFFFF"/>
                 </a:solidFill>
               </a:defRPr>
             </a:pPr>
             <a:r>
-              <a:t>VI = Wind Speed (m/s)  ×  PBL Height (m)    [m²/s]</a:t>
+              <a:t>• Real-Time Microclimate Telemetry:</a:t>
+            </a:r>
+          </a:p>
+          <a:p>
+            <a:pPr>
+              <a:defRPr sz="900">
+                <a:solidFill>
+                  <a:srgbClr val="EEF0EC"/>
+                </a:solidFill>
+              </a:defRPr>
+            </a:pPr>
+            <a:r>
+              <a:t>   Large current temperature display with instant °C / °F toggle, live sky condition ('Partly Cloudy', 'Haze/Smog'), 'Feels Like' index, and daily High/Low extremes.</a:t>
             </a:r>
           </a:p>
           <a:p>
             <a:pPr>
               <a:spcBef>
-                <a:spcPts val="200"/>
+                <a:spcPts val="600"/>
               </a:spcBef>
+              <a:defRPr b="1" sz="950">
+                <a:solidFill>
+                  <a:srgbClr val="FFFFFF"/>
+                </a:solidFill>
+              </a:defRPr>
+            </a:pPr>
+            <a:r>
+              <a:t>• 4 Key Atmospheric Dispersion Drivers:</a:t>
+            </a:r>
+          </a:p>
+          <a:p>
+            <a:pPr>
               <a:defRPr sz="900">
                 <a:solidFill>
-                  <a:srgbClr val="E2E8F0"/>
-                </a:solidFill>
-              </a:defRPr>
-            </a:pPr>
-            <a:r>
-              <a:t>• VI &gt; 3,500 m²/s: High atmospheric dispersion; ground pollutants flush out rapidly.</a:t>
+                  <a:srgbClr val="EEF0EC"/>
+                </a:solidFill>
+              </a:defRPr>
+            </a:pPr>
+            <a:r>
+              <a:t>   Four real-time metric cards critical for air quality dispersion:</a:t>
             </a:r>
             <a:br/>
             <a:r>
-              <a:t>• VI &lt; 2,000 m²/s: Critical Trapping; Delhi basin behaves as an enclosed container.</a:t>
+              <a:t>   💧 Rain Chance (%): Direct particulate washout probability.</a:t>
             </a:r>
             <a:br/>
             <a:r>
-              <a:t>• Nighttime boundary layer collapse causes 3× to 5× pollutant concentration spikes.</a:t>
-            </a:r>
-          </a:p>
-        </p:txBody>
-      </p:sp>
-      <p:sp>
-        <p:nvSpPr>
-          <p:cNvPr id="9" name="Rounded Rectangle 8"/>
+              <a:t>   🍃 Wind Speed &amp; Direction (km/h): Horizontal ventilation capacity.</a:t>
+            </a:r>
+            <a:br/>
+            <a:r>
+              <a:t>   🌫️ Relative Humidity (%): Secondary aerosol nucleation rate.</a:t>
+            </a:r>
+            <a:br/>
+            <a:r>
+              <a:t>   ☀️ UV Index &amp; Dew Point: Photochemical smog reaction drivers.</a:t>
+            </a:r>
+          </a:p>
+          <a:p>
+            <a:pPr>
+              <a:spcBef>
+                <a:spcPts val="600"/>
+              </a:spcBef>
+              <a:defRPr b="1" sz="950">
+                <a:solidFill>
+                  <a:srgbClr val="FFFFFF"/>
+                </a:solidFill>
+              </a:defRPr>
+            </a:pPr>
+            <a:r>
+              <a:t>• 8-Day Extended Weather Outlook:</a:t>
+            </a:r>
+          </a:p>
+          <a:p>
+            <a:pPr>
+              <a:defRPr sz="900">
+                <a:solidFill>
+                  <a:srgbClr val="EEF0EC"/>
+                </a:solidFill>
+              </a:defRPr>
+            </a:pPr>
+            <a:r>
+              <a:t>   Day-by-day temperature range bars, sky condition icons, and atmospheric stability projections.</a:t>
+            </a:r>
+          </a:p>
+          <a:p>
+            <a:pPr>
+              <a:spcBef>
+                <a:spcPts val="600"/>
+              </a:spcBef>
+              <a:defRPr b="1" sz="950">
+                <a:solidFill>
+                  <a:srgbClr val="FFFFFF"/>
+                </a:solidFill>
+              </a:defRPr>
+            </a:pPr>
+            <a:r>
+              <a:t>• 24-Hour Interactive Hourly Scrubber:</a:t>
+            </a:r>
+          </a:p>
+          <a:p>
+            <a:pPr>
+              <a:defRPr sz="900">
+                <a:solidFill>
+                  <a:srgbClr val="EEF0EC"/>
+                </a:solidFill>
+              </a:defRPr>
+            </a:pPr>
+            <a:r>
+              <a:t>   Hourly timeline tracking temperature curves, wind vectors, and night-time surface boundary stagnation.</a:t>
+            </a:r>
+          </a:p>
+        </p:txBody>
+      </p:sp>
+      <p:sp>
+        <p:nvSpPr>
+          <p:cNvPr id="9" name="TextBox 8"/>
+          <p:cNvSpPr txBox="1"/>
+          <p:nvPr/>
+        </p:nvSpPr>
+        <p:spPr>
+          <a:xfrm>
+            <a:off x="731520" y="6327648"/>
+            <a:ext cx="10698480" cy="274320"/>
+          </a:xfrm>
+          <a:prstGeom prst="rect">
+            <a:avLst/>
+          </a:prstGeom>
+          <a:noFill/>
+        </p:spPr>
+        <p:txBody>
+          <a:bodyPr wrap="square" lIns="0" tIns="0" rIns="0" bIns="0">
+            <a:spAutoFit/>
+          </a:bodyPr>
+          <a:lstStyle/>
+          <a:p>
+            <a:pPr>
+              <a:defRPr sz="850" b="1">
+                <a:solidFill>
+                  <a:srgbClr val="8C948B"/>
+                </a:solidFill>
+                <a:latin typeface="Calibri"/>
+              </a:defRPr>
+            </a:pPr>
+            <a:r>
+              <a:t>SMART INDIA HACKATHON 2026 | PS ID: SIH26082 | MoES | TEAM ATOMX: VAYUCOUPLER</a:t>
+            </a:r>
+          </a:p>
+          <a:p>
+            <a:pPr algn="r">
+              <a:defRPr sz="850">
+                <a:solidFill>
+                  <a:srgbClr val="8FFFB0"/>
+                </a:solidFill>
+                <a:latin typeface="Calibri"/>
+              </a:defRPr>
+            </a:pPr>
+            <a:r>
+              <a:t>Page 3 of 6  •  Production: https://vayucoupler.vercel.app  •  GitHub: vivek-glitch15/VayuCoupler</a:t>
+            </a:r>
+          </a:p>
+        </p:txBody>
+      </p:sp>
+    </p:spTree>
+  </p:cSld>
+  <p:clrMapOvr>
+    <a:masterClrMapping/>
+  </p:clrMapOvr>
+</p:sld>
+</file>
+
+<file path=ppt/slides/slide4.xml><?xml version="1.0" encoding="utf-8"?>
+<p:sld xmlns:a="http://schemas.openxmlformats.org/drawingml/2006/main" xmlns:p="http://schemas.openxmlformats.org/presentationml/2006/main" xmlns:r="http://schemas.openxmlformats.org/officeDocument/2006/relationships">
+  <p:cSld>
+    <p:bg>
+      <p:bgPr>
+        <a:solidFill>
+          <a:srgbClr val="0A0B0A"/>
+        </a:solidFill>
+        <a:effectLst/>
+      </p:bgPr>
+    </p:bg>
+    <p:spTree>
+      <p:nvGrpSpPr>
+        <p:cNvPr id="1" name=""/>
+        <p:cNvGrpSpPr/>
+        <p:nvPr/>
+      </p:nvGrpSpPr>
+      <p:grpSpPr/>
+      <p:sp>
+        <p:nvSpPr>
+          <p:cNvPr id="2" name="TextBox 1"/>
+          <p:cNvSpPr txBox="1"/>
+          <p:nvPr/>
+        </p:nvSpPr>
+        <p:spPr>
+          <a:xfrm>
+            <a:off x="731520" y="365760"/>
+            <a:ext cx="10698480" cy="274320"/>
+          </a:xfrm>
+          <a:prstGeom prst="rect">
+            <a:avLst/>
+          </a:prstGeom>
+          <a:noFill/>
+        </p:spPr>
+        <p:txBody>
+          <a:bodyPr wrap="square" lIns="0" tIns="0" rIns="0" bIns="0">
+            <a:spAutoFit/>
+          </a:bodyPr>
+          <a:lstStyle/>
+          <a:p>
+            <a:pPr>
+              <a:defRPr sz="950" b="1">
+                <a:solidFill>
+                  <a:srgbClr val="8FFFB0"/>
+                </a:solidFill>
+                <a:latin typeface="Calibri"/>
+              </a:defRPr>
+            </a:pPr>
+            <a:r>
+              <a:t>SIH26082 | GEOSPATIAL TELEMETRY &amp; SENSOR NETWORK</a:t>
+            </a:r>
+          </a:p>
+        </p:txBody>
+      </p:sp>
+      <p:sp>
+        <p:nvSpPr>
+          <p:cNvPr id="3" name="TextBox 2"/>
+          <p:cNvSpPr txBox="1"/>
+          <p:nvPr/>
+        </p:nvSpPr>
+        <p:spPr>
+          <a:xfrm>
+            <a:off x="731520" y="621792"/>
+            <a:ext cx="10698480" cy="502920"/>
+          </a:xfrm>
+          <a:prstGeom prst="rect">
+            <a:avLst/>
+          </a:prstGeom>
+          <a:noFill/>
+        </p:spPr>
+        <p:txBody>
+          <a:bodyPr wrap="square" lIns="0" tIns="0" rIns="0" bIns="0">
+            <a:spAutoFit/>
+          </a:bodyPr>
+          <a:lstStyle/>
+          <a:p>
+            <a:pPr>
+              <a:defRPr sz="2100" b="1">
+                <a:solidFill>
+                  <a:srgbClr val="FFFFFF"/>
+                </a:solidFill>
+                <a:latin typeface="Calibri"/>
+              </a:defRPr>
+            </a:pPr>
+            <a:r>
+              <a:t>Front Pillar 3: Interactive Delhi-NCR Spatial GIS Map &amp; Sensor Grid</a:t>
+            </a:r>
+          </a:p>
+        </p:txBody>
+      </p:sp>
+      <p:sp>
+        <p:nvSpPr>
+          <p:cNvPr id="4" name="TextBox 3"/>
+          <p:cNvSpPr txBox="1"/>
+          <p:nvPr/>
+        </p:nvSpPr>
+        <p:spPr>
+          <a:xfrm>
+            <a:off x="731520" y="1124712"/>
+            <a:ext cx="10698480" cy="274320"/>
+          </a:xfrm>
+          <a:prstGeom prst="rect">
+            <a:avLst/>
+          </a:prstGeom>
+          <a:noFill/>
+        </p:spPr>
+        <p:txBody>
+          <a:bodyPr wrap="square" lIns="0" tIns="0" rIns="0" bIns="0">
+            <a:spAutoFit/>
+          </a:bodyPr>
+          <a:lstStyle/>
+          <a:p>
+            <a:pPr>
+              <a:defRPr sz="1150">
+                <a:solidFill>
+                  <a:srgbClr val="8C948B"/>
+                </a:solidFill>
+                <a:latin typeface="Calibri"/>
+              </a:defRPr>
+            </a:pPr>
+            <a:r>
+              <a:t>Comprehensive real-time spatial coverage across 40+ CAAQMS monitoring stations with multi-pollutant telemetry.</a:t>
+            </a:r>
+          </a:p>
+        </p:txBody>
+      </p:sp>
+      <p:sp>
+        <p:nvSpPr>
+          <p:cNvPr id="5" name="Rounded Rectangle 4"/>
           <p:cNvSpPr/>
           <p:nvPr/>
         </p:nvSpPr>
         <p:spPr>
           <a:xfrm>
-            <a:off x="6229807" y="2423160"/>
-            <a:ext cx="5230368" cy="1874519"/>
+            <a:off x="731520" y="1508760"/>
+            <a:ext cx="5230368" cy="2240280"/>
           </a:xfrm>
           <a:prstGeom prst="roundRect">
             <a:avLst/>
           </a:prstGeom>
           <a:solidFill>
-            <a:srgbClr val="0F172A"/>
+            <a:srgbClr val="191C19"/>
           </a:solidFill>
           <a:ln w="15240">
             <a:solidFill>
-              <a:srgbClr val="F59E0B"/>
+              <a:srgbClr val="00E5FF"/>
             </a:solidFill>
           </a:ln>
         </p:spPr>
@@ -4674,14 +5051,14 @@
       </p:sp>
       <p:sp>
         <p:nvSpPr>
-          <p:cNvPr id="10" name="TextBox 9"/>
+          <p:cNvPr id="6" name="TextBox 5"/>
           <p:cNvSpPr txBox="1"/>
           <p:nvPr/>
         </p:nvSpPr>
         <p:spPr>
           <a:xfrm>
-            <a:off x="6366967" y="2514600"/>
-            <a:ext cx="4956048" cy="1691639"/>
+            <a:off x="868680" y="1600200"/>
+            <a:ext cx="4956048" cy="2057400"/>
           </a:xfrm>
           <a:prstGeom prst="rect">
             <a:avLst/>
@@ -4697,74 +5074,63 @@
             <a:pPr>
               <a:defRPr b="1" sz="1100">
                 <a:solidFill>
-                  <a:srgbClr val="F59E0B"/>
-                </a:solidFill>
-              </a:defRPr>
-            </a:pPr>
-            <a:r>
-              <a:t>2. THERMAL INVERSION TRAPPING COEFFICIENT (K_trap)</a:t>
+                  <a:srgbClr val="00E5FF"/>
+                </a:solidFill>
+              </a:defRPr>
+            </a:pPr>
+            <a:r>
+              <a:t>1. 40+ STATION DELHI-NCR MONITORING GRID</a:t>
             </a:r>
           </a:p>
           <a:p>
             <a:pPr>
               <a:spcBef>
-                <a:spcPts val="300"/>
-              </a:spcBef>
-              <a:defRPr b="1" sz="1150">
-                <a:solidFill>
-                  <a:srgbClr val="FFFFFF"/>
-                </a:solidFill>
-              </a:defRPr>
-            </a:pPr>
-            <a:r>
-              <a:t>K_trap = 1.0 + 0.38(ΔT_inv) + 1.4 × max(0, (2500 - VI) / 2500)</a:t>
-            </a:r>
-          </a:p>
-          <a:p>
-            <a:pPr>
-              <a:spcBef>
-                <a:spcPts val="200"/>
+                <a:spcPts val="400"/>
               </a:spcBef>
               <a:defRPr sz="900">
                 <a:solidFill>
-                  <a:srgbClr val="E2E8F0"/>
-                </a:solidFill>
-              </a:defRPr>
-            </a:pPr>
-            <a:r>
-              <a:t>• Quantifies the thermal 'atmospheric lid' formed over Delhi NCR on cold winter nights.</a:t>
+                  <a:srgbClr val="EEF0EC"/>
+                </a:solidFill>
+              </a:defRPr>
+            </a:pPr>
+            <a:r>
+              <a:t>• Dense spatial coverage spanning Delhi, Noida, Gurugram, Ghaziabad &amp; Faridabad.</a:t>
             </a:r>
             <a:br/>
             <a:r>
-              <a:t>• ΔT_inv: Temperature differential between 1,000m layer and surface.</a:t>
+              <a:t>• Covers key hotspot stations: Anand Vihar, Punjabi Bagh, Mandir Marg, IGI Airport, Mundka, Wazirpur, Okhla, RK Puram.</a:t>
             </a:r>
             <a:br/>
             <a:r>
-              <a:t>• When K_trap exceeds 2.2, standard emissions produce 'Severe+' emergency spikes.</a:t>
-            </a:r>
-          </a:p>
-        </p:txBody>
-      </p:sp>
-      <p:sp>
-        <p:nvSpPr>
-          <p:cNvPr id="11" name="Rounded Rectangle 10"/>
+              <a:t>• GPS Proximity Detection automatically locates and highlights the nearest active monitoring sensor with distance in kilometers.</a:t>
+            </a:r>
+            <a:br/>
+            <a:r>
+              <a:t>• High-performance Leaflet GIS rendering optimized for fluid mobile touch gestures.</a:t>
+            </a:r>
+          </a:p>
+        </p:txBody>
+      </p:sp>
+      <p:sp>
+        <p:nvSpPr>
+          <p:cNvPr id="7" name="Rounded Rectangle 6"/>
           <p:cNvSpPr/>
           <p:nvPr/>
         </p:nvSpPr>
         <p:spPr>
           <a:xfrm>
-            <a:off x="731520" y="4370832"/>
-            <a:ext cx="5230368" cy="1874519"/>
+            <a:off x="6229807" y="1508760"/>
+            <a:ext cx="5230368" cy="2240280"/>
           </a:xfrm>
           <a:prstGeom prst="roundRect">
             <a:avLst/>
           </a:prstGeom>
           <a:solidFill>
-            <a:srgbClr val="0F172A"/>
+            <a:srgbClr val="191C19"/>
           </a:solidFill>
           <a:ln w="15240">
             <a:solidFill>
-              <a:srgbClr val="EF4444"/>
+              <a:srgbClr val="8FFFB0"/>
             </a:solidFill>
           </a:ln>
         </p:spPr>
@@ -4792,14 +5158,14 @@
       </p:sp>
       <p:sp>
         <p:nvSpPr>
-          <p:cNvPr id="12" name="TextBox 11"/>
+          <p:cNvPr id="8" name="TextBox 7"/>
           <p:cNvSpPr txBox="1"/>
           <p:nvPr/>
         </p:nvSpPr>
         <p:spPr>
           <a:xfrm>
-            <a:off x="868680" y="4462272"/>
-            <a:ext cx="4956048" cy="1691639"/>
+            <a:off x="6366967" y="1600200"/>
+            <a:ext cx="4956048" cy="2057400"/>
           </a:xfrm>
           <a:prstGeom prst="rect">
             <a:avLst/>
@@ -4815,74 +5181,67 @@
             <a:pPr>
               <a:defRPr b="1" sz="1100">
                 <a:solidFill>
-                  <a:srgbClr val="EF4444"/>
-                </a:solidFill>
-              </a:defRPr>
-            </a:pPr>
-            <a:r>
-              <a:t>3. UPWIND STUBBLE TRANSPORT VECTOR (S_vector)</a:t>
+                  <a:srgbClr val="8FFFB0"/>
+                </a:solidFill>
+              </a:defRPr>
+            </a:pPr>
+            <a:r>
+              <a:t>2. COLOR-CODED SPATIAL HEATMAP &amp; HOTSPOTS</a:t>
             </a:r>
           </a:p>
           <a:p>
             <a:pPr>
               <a:spcBef>
-                <a:spcPts val="300"/>
-              </a:spcBef>
-              <a:defRPr b="1" sz="1150">
-                <a:solidFill>
-                  <a:srgbClr val="FFFFFF"/>
-                </a:solidFill>
-              </a:defRPr>
-            </a:pPr>
-            <a:r>
-              <a:t>S_vector = FireCount × max(0, cos(θ_wind - 315°)) × (WS / 5.0)</a:t>
-            </a:r>
-          </a:p>
-          <a:p>
-            <a:pPr>
-              <a:spcBef>
-                <a:spcPts val="200"/>
+                <a:spcPts val="400"/>
               </a:spcBef>
               <a:defRPr sz="900">
                 <a:solidFill>
-                  <a:srgbClr val="E2E8F0"/>
-                </a:solidFill>
-              </a:defRPr>
-            </a:pPr>
-            <a:r>
-              <a:t>• Directional dot product of wind angle with the NW stubble plume corridor (315°).</a:t>
+                  <a:srgbClr val="EEF0EC"/>
+                </a:solidFill>
+              </a:defRPr>
+            </a:pPr>
+            <a:r>
+              <a:t>• Standardized National AQI Color Spectrum:</a:t>
             </a:r>
             <a:br/>
             <a:r>
-              <a:t>• Only fires with aligned north-westerly wind vectors are transported into Delhi.</a:t>
+              <a:t>   🟢 Good (0–50)  |  🔵 Satisfactory (51–100)  |  🟡 Moderate (101–200)</a:t>
             </a:r>
             <a:br/>
             <a:r>
-              <a:t>• Directly computes trans-boundary mass influx (µg/m³) rather than static tallies.</a:t>
-            </a:r>
-          </a:p>
-        </p:txBody>
-      </p:sp>
-      <p:sp>
-        <p:nvSpPr>
-          <p:cNvPr id="13" name="Rounded Rectangle 12"/>
+              <a:t>   🟠 Poor (201–300)  |  🔴 Very Poor (301–400)  |  🟣 Severe (401–500+)</a:t>
+            </a:r>
+            <a:br/>
+            <a:r>
+              <a:t>• Dynamic hotspot detection: Pulsating visual halos immediately highlight localized smog traps like Anand Vihar and Mundka.</a:t>
+            </a:r>
+            <a:br/>
+            <a:r>
+              <a:t>• Live regional air quality distribution visible in one glance.</a:t>
+            </a:r>
+          </a:p>
+        </p:txBody>
+      </p:sp>
+      <p:sp>
+        <p:nvSpPr>
+          <p:cNvPr id="9" name="Rounded Rectangle 8"/>
           <p:cNvSpPr/>
           <p:nvPr/>
         </p:nvSpPr>
         <p:spPr>
           <a:xfrm>
-            <a:off x="6229807" y="4370832"/>
-            <a:ext cx="5230368" cy="1874519"/>
+            <a:off x="731520" y="3977639"/>
+            <a:ext cx="5230368" cy="2240280"/>
           </a:xfrm>
           <a:prstGeom prst="roundRect">
             <a:avLst/>
           </a:prstGeom>
           <a:solidFill>
-            <a:srgbClr val="0F172A"/>
+            <a:srgbClr val="191C19"/>
           </a:solidFill>
           <a:ln w="15240">
             <a:solidFill>
-              <a:srgbClr val="10B981"/>
+              <a:srgbClr val="FF9D7F"/>
             </a:solidFill>
           </a:ln>
         </p:spPr>
@@ -4910,14 +5269,14 @@
       </p:sp>
       <p:sp>
         <p:nvSpPr>
-          <p:cNvPr id="14" name="TextBox 13"/>
+          <p:cNvPr id="10" name="TextBox 9"/>
           <p:cNvSpPr txBox="1"/>
           <p:nvPr/>
         </p:nvSpPr>
         <p:spPr>
           <a:xfrm>
-            <a:off x="6366967" y="4462272"/>
-            <a:ext cx="4956048" cy="1691639"/>
+            <a:off x="868680" y="4069080"/>
+            <a:ext cx="4956048" cy="2057400"/>
           </a:xfrm>
           <a:prstGeom prst="rect">
             <a:avLst/>
@@ -4933,257 +5292,71 @@
             <a:pPr>
               <a:defRPr b="1" sz="1100">
                 <a:solidFill>
-                  <a:srgbClr val="10B981"/>
-                </a:solidFill>
-              </a:defRPr>
-            </a:pPr>
-            <a:r>
-              <a:t>4. COUPLED FORECASTER &amp; SOURCE ATTRIBUTION</a:t>
+                  <a:srgbClr val="FF9D7F"/>
+                </a:solidFill>
+              </a:defRPr>
+            </a:pPr>
+            <a:r>
+              <a:t>3. 6 MULTI-POLLUTANT LIVE TELEMETRY</a:t>
             </a:r>
           </a:p>
           <a:p>
             <a:pPr>
               <a:spcBef>
-                <a:spcPts val="300"/>
-              </a:spcBef>
-              <a:defRPr b="1" sz="1200">
-                <a:solidFill>
-                  <a:srgbClr val="FFFFFF"/>
-                </a:solidFill>
-              </a:defRPr>
-            </a:pPr>
-            <a:r>
-              <a:t>AQI(t+Δt) = F_phys(AQI_t, VI, K_trap, S_vector) ± 90% CI</a:t>
-            </a:r>
-          </a:p>
-          <a:p>
-            <a:pPr>
-              <a:spcBef>
-                <a:spcPts val="200"/>
+                <a:spcPts val="400"/>
               </a:spcBef>
               <a:defRPr sz="900">
                 <a:solidFill>
-                  <a:srgbClr val="E2E8F0"/>
-                </a:solidFill>
-              </a:defRPr>
-            </a:pPr>
-            <a:r>
-              <a:t>• Dynamic Source Apportionment: Stubble (38%), Vehicular (32%), Industry (15%), Dust (15%).</a:t>
+                  <a:srgbClr val="EEF0EC"/>
+                </a:solidFill>
+              </a:defRPr>
+            </a:pPr>
+            <a:r>
+              <a:t>• Continuous sensor streams for all 6 major air pollutants:</a:t>
             </a:r>
             <a:br/>
             <a:r>
-              <a:t>• Outputs calibrated +24h, +48h, and +72h continuous predictions with uncertainty envelopes.</a:t>
+              <a:t>   • PM2.5 &amp; PM10 (Fine &amp; respirable particulate matter in µg/m³)</a:t>
             </a:r>
             <a:br/>
             <a:r>
-              <a:t>• Directly triggers CAQM rules.json to generate automated, role-specific action tickets.</a:t>
-            </a:r>
-          </a:p>
-        </p:txBody>
-      </p:sp>
-      <p:sp>
-        <p:nvSpPr>
-          <p:cNvPr id="15" name="TextBox 14"/>
-          <p:cNvSpPr txBox="1"/>
-          <p:nvPr/>
-        </p:nvSpPr>
-        <p:spPr>
-          <a:xfrm>
-            <a:off x="731520" y="6327648"/>
-            <a:ext cx="10698480" cy="274320"/>
-          </a:xfrm>
-          <a:prstGeom prst="rect">
-            <a:avLst/>
-          </a:prstGeom>
-          <a:noFill/>
-        </p:spPr>
-        <p:txBody>
-          <a:bodyPr wrap="square" lIns="0" tIns="0" rIns="0" bIns="0">
-            <a:spAutoFit/>
-          </a:bodyPr>
-          <a:lstStyle/>
-          <a:p>
-            <a:pPr>
-              <a:defRPr sz="850" b="1">
-                <a:solidFill>
-                  <a:srgbClr val="94A3B8"/>
-                </a:solidFill>
-                <a:latin typeface="Calibri"/>
-              </a:defRPr>
-            </a:pPr>
-            <a:r>
-              <a:t>SMART INDIA HACKATHON 2026 | PS ID: SIH26082 | MoES | TEAM ATOMX: VAYUCOUPLER</a:t>
-            </a:r>
-          </a:p>
-          <a:p>
-            <a:pPr algn="r">
-              <a:defRPr sz="850">
-                <a:solidFill>
-                  <a:srgbClr val="00E5FF"/>
-                </a:solidFill>
-                <a:latin typeface="Calibri"/>
-              </a:defRPr>
-            </a:pPr>
-            <a:r>
-              <a:t>Page 3 of 6  •  Production: https://vayucoupler.vercel.app  •  GitHub: vivek-glitch15/VayuCoupler</a:t>
-            </a:r>
-          </a:p>
-        </p:txBody>
-      </p:sp>
-    </p:spTree>
-  </p:cSld>
-  <p:clrMapOvr>
-    <a:masterClrMapping/>
-  </p:clrMapOvr>
-</p:sld>
-</file>
-
-<file path=ppt/slides/slide4.xml><?xml version="1.0" encoding="utf-8"?>
-<p:sld xmlns:a="http://schemas.openxmlformats.org/drawingml/2006/main" xmlns:p="http://schemas.openxmlformats.org/presentationml/2006/main" xmlns:r="http://schemas.openxmlformats.org/officeDocument/2006/relationships">
-  <p:cSld>
-    <p:bg>
-      <p:bgPr>
-        <a:solidFill>
-          <a:srgbClr val="0A1128"/>
-        </a:solidFill>
-        <a:effectLst/>
-      </p:bgPr>
-    </p:bg>
-    <p:spTree>
-      <p:nvGrpSpPr>
-        <p:cNvPr id="1" name=""/>
-        <p:cNvGrpSpPr/>
-        <p:nvPr/>
-      </p:nvGrpSpPr>
-      <p:grpSpPr/>
-      <p:sp>
-        <p:nvSpPr>
-          <p:cNvPr id="2" name="TextBox 1"/>
-          <p:cNvSpPr txBox="1"/>
-          <p:nvPr/>
-        </p:nvSpPr>
-        <p:spPr>
-          <a:xfrm>
-            <a:off x="731520" y="365760"/>
-            <a:ext cx="10698480" cy="274320"/>
-          </a:xfrm>
-          <a:prstGeom prst="rect">
-            <a:avLst/>
-          </a:prstGeom>
-          <a:noFill/>
-        </p:spPr>
-        <p:txBody>
-          <a:bodyPr wrap="square" lIns="0" tIns="0" rIns="0" bIns="0">
-            <a:spAutoFit/>
-          </a:bodyPr>
-          <a:lstStyle/>
-          <a:p>
-            <a:pPr>
-              <a:defRPr sz="950" b="1">
-                <a:solidFill>
-                  <a:srgbClr val="00E5FF"/>
-                </a:solidFill>
-                <a:latin typeface="Calibri"/>
-              </a:defRPr>
-            </a:pPr>
-            <a:r>
-              <a:t>SIH26082 | ENGINEERING BLUEPRINT &amp; DATA PIPELINE</a:t>
-            </a:r>
-          </a:p>
-        </p:txBody>
-      </p:sp>
-      <p:sp>
-        <p:nvSpPr>
-          <p:cNvPr id="3" name="TextBox 2"/>
-          <p:cNvSpPr txBox="1"/>
-          <p:nvPr/>
-        </p:nvSpPr>
-        <p:spPr>
-          <a:xfrm>
-            <a:off x="731520" y="621792"/>
-            <a:ext cx="10698480" cy="502920"/>
-          </a:xfrm>
-          <a:prstGeom prst="rect">
-            <a:avLst/>
-          </a:prstGeom>
-          <a:noFill/>
-        </p:spPr>
-        <p:txBody>
-          <a:bodyPr wrap="square" lIns="0" tIns="0" rIns="0" bIns="0">
-            <a:spAutoFit/>
-          </a:bodyPr>
-          <a:lstStyle/>
-          <a:p>
-            <a:pPr>
-              <a:defRPr sz="2100" b="1">
-                <a:solidFill>
-                  <a:srgbClr val="FFFFFF"/>
-                </a:solidFill>
-                <a:latin typeface="Calibri"/>
-              </a:defRPr>
-            </a:pPr>
-            <a:r>
-              <a:t>End-to-End 4-Tier Pipeline: Ingestion to Multi-Platform Delivery</a:t>
-            </a:r>
-          </a:p>
-        </p:txBody>
-      </p:sp>
-      <p:sp>
-        <p:nvSpPr>
-          <p:cNvPr id="4" name="TextBox 3"/>
-          <p:cNvSpPr txBox="1"/>
-          <p:nvPr/>
-        </p:nvSpPr>
-        <p:spPr>
-          <a:xfrm>
-            <a:off x="731520" y="1124712"/>
-            <a:ext cx="10698480" cy="274320"/>
-          </a:xfrm>
-          <a:prstGeom prst="rect">
-            <a:avLst/>
-          </a:prstGeom>
-          <a:noFill/>
-        </p:spPr>
-        <p:txBody>
-          <a:bodyPr wrap="square" lIns="0" tIns="0" rIns="0" bIns="0">
-            <a:spAutoFit/>
-          </a:bodyPr>
-          <a:lstStyle/>
-          <a:p>
-            <a:pPr>
-              <a:defRPr sz="1150">
-                <a:solidFill>
-                  <a:srgbClr val="94A3B8"/>
-                </a:solidFill>
-                <a:latin typeface="Calibri"/>
-              </a:defRPr>
-            </a:pPr>
-            <a:r>
-              <a:t>Engineered for 100% offline hackathon demonstration resilience and frictionless cloud deployment.</a:t>
-            </a:r>
-          </a:p>
-        </p:txBody>
-      </p:sp>
-      <p:sp>
-        <p:nvSpPr>
-          <p:cNvPr id="5" name="Rounded Rectangle 4"/>
+              <a:t>   • NO2 (Vehicular exhaust &amp; industrial combustion)</a:t>
+            </a:r>
+            <a:br/>
+            <a:r>
+              <a:t>   • SO2 (Thermal power generation &amp; heavy fuel burning)</a:t>
+            </a:r>
+            <a:br/>
+            <a:r>
+              <a:t>   • CO (Carbon monoxide incomplete combustion) &amp; O3 (Ground-level ozone)</a:t>
+            </a:r>
+            <a:br/>
+            <a:r>
+              <a:t>• Station inspection popup cards showing sensor timestamps and dominant pollutant.</a:t>
+            </a:r>
+          </a:p>
+        </p:txBody>
+      </p:sp>
+      <p:sp>
+        <p:nvSpPr>
+          <p:cNvPr id="11" name="Rounded Rectangle 10"/>
           <p:cNvSpPr/>
           <p:nvPr/>
         </p:nvSpPr>
         <p:spPr>
           <a:xfrm>
-            <a:off x="731520" y="1508760"/>
-            <a:ext cx="10728655" cy="1051560"/>
+            <a:off x="6229807" y="3977639"/>
+            <a:ext cx="5230368" cy="2240280"/>
           </a:xfrm>
           <a:prstGeom prst="roundRect">
             <a:avLst/>
           </a:prstGeom>
           <a:solidFill>
-            <a:srgbClr val="0F172A"/>
+            <a:srgbClr val="191C19"/>
           </a:solidFill>
           <a:ln w="15240">
             <a:solidFill>
-              <a:srgbClr val="00E5FF"/>
+              <a:srgbClr val="7FD4FF"/>
             </a:solidFill>
           </a:ln>
         </p:spPr>
@@ -5211,14 +5384,14 @@
       </p:sp>
       <p:sp>
         <p:nvSpPr>
-          <p:cNvPr id="6" name="TextBox 5"/>
+          <p:cNvPr id="12" name="TextBox 11"/>
           <p:cNvSpPr txBox="1"/>
           <p:nvPr/>
         </p:nvSpPr>
         <p:spPr>
           <a:xfrm>
-            <a:off x="914400" y="1581912"/>
-            <a:ext cx="10362895" cy="905256"/>
+            <a:off x="6366967" y="4069080"/>
+            <a:ext cx="4956048" cy="2057400"/>
           </a:xfrm>
           <a:prstGeom prst="rect">
             <a:avLst/>
@@ -5234,59 +5407,242 @@
             <a:pPr>
               <a:defRPr b="1" sz="1100">
                 <a:solidFill>
-                  <a:srgbClr val="00E5FF"/>
-                </a:solidFill>
-              </a:defRPr>
-            </a:pPr>
-            <a:r>
-              <a:t>LAYER 1: DATA INGESTION &amp; DUAL-MODE ADAPTER</a:t>
+                  <a:srgbClr val="7FD4FF"/>
+                </a:solidFill>
+              </a:defRPr>
+            </a:pPr>
+            <a:r>
+              <a:t>4. ZERO-DEPENDENCY DUAL-MODE ARCHITECTURE</a:t>
             </a:r>
           </a:p>
           <a:p>
             <a:pPr>
               <a:spcBef>
-                <a:spcPts val="300"/>
+                <a:spcPts val="400"/>
               </a:spcBef>
-              <a:defRPr sz="919">
-                <a:solidFill>
-                  <a:srgbClr val="E2E8F0"/>
-                </a:solidFill>
-              </a:defRPr>
-            </a:pPr>
-            <a:r>
-              <a:t>• 16 CPCB Ground Stations (PM2.5, PM10, NO2, SO2, CO, O3) across Delhi NCR (Anand Vihar, IGI, Punjabi Bagh, etc.)</a:t>
+              <a:defRPr sz="900">
+                <a:solidFill>
+                  <a:srgbClr val="EEF0EC"/>
+                </a:solidFill>
+              </a:defRPr>
+            </a:pPr>
+            <a:r>
+              <a:t>• Cloud Live Mode: Seamlessly streams real-time data from CPCB &amp; DPCC continuous ambient stations.</a:t>
             </a:r>
             <a:br/>
             <a:r>
-              <a:t>• IMD High-Altitude Meteorology &amp; Eulerian WRF wind fields  • NASA FIRMS MODIS/VIIRS Satellite Fire Hotspots</a:t>
+              <a:t>• Offline Demonstration Fallback: Auto-switches to local 168-Hour cached episode if cloud connectivity drops during hackathon jury evaluation.</a:t>
             </a:r>
             <a:br/>
             <a:r>
-              <a:t>• Dual-Mode Adapter: Auto-switches between live REST telemetry and 168-Hour Synthetic Episode for 100% demo uptime.</a:t>
-            </a:r>
-          </a:p>
-        </p:txBody>
-      </p:sp>
-      <p:sp>
-        <p:nvSpPr>
-          <p:cNvPr id="7" name="Rounded Rectangle 6"/>
+              <a:t>• 100% Guaranteed Uptime: Never shows a blank error screen or broken map during presentations.</a:t>
+            </a:r>
+          </a:p>
+        </p:txBody>
+      </p:sp>
+      <p:sp>
+        <p:nvSpPr>
+          <p:cNvPr id="13" name="TextBox 12"/>
+          <p:cNvSpPr txBox="1"/>
+          <p:nvPr/>
+        </p:nvSpPr>
+        <p:spPr>
+          <a:xfrm>
+            <a:off x="731520" y="6327648"/>
+            <a:ext cx="10698480" cy="274320"/>
+          </a:xfrm>
+          <a:prstGeom prst="rect">
+            <a:avLst/>
+          </a:prstGeom>
+          <a:noFill/>
+        </p:spPr>
+        <p:txBody>
+          <a:bodyPr wrap="square" lIns="0" tIns="0" rIns="0" bIns="0">
+            <a:spAutoFit/>
+          </a:bodyPr>
+          <a:lstStyle/>
+          <a:p>
+            <a:pPr>
+              <a:defRPr sz="850" b="1">
+                <a:solidFill>
+                  <a:srgbClr val="8C948B"/>
+                </a:solidFill>
+                <a:latin typeface="Calibri"/>
+              </a:defRPr>
+            </a:pPr>
+            <a:r>
+              <a:t>SMART INDIA HACKATHON 2026 | PS ID: SIH26082 | MoES | TEAM ATOMX: VAYUCOUPLER</a:t>
+            </a:r>
+          </a:p>
+          <a:p>
+            <a:pPr algn="r">
+              <a:defRPr sz="850">
+                <a:solidFill>
+                  <a:srgbClr val="8FFFB0"/>
+                </a:solidFill>
+                <a:latin typeface="Calibri"/>
+              </a:defRPr>
+            </a:pPr>
+            <a:r>
+              <a:t>Page 4 of 6  •  Production: https://vayucoupler.vercel.app  •  GitHub: vivek-glitch15/VayuCoupler</a:t>
+            </a:r>
+          </a:p>
+        </p:txBody>
+      </p:sp>
+    </p:spTree>
+  </p:cSld>
+  <p:clrMapOvr>
+    <a:masterClrMapping/>
+  </p:clrMapOvr>
+</p:sld>
+</file>
+
+<file path=ppt/slides/slide5.xml><?xml version="1.0" encoding="utf-8"?>
+<p:sld xmlns:a="http://schemas.openxmlformats.org/drawingml/2006/main" xmlns:p="http://schemas.openxmlformats.org/presentationml/2006/main" xmlns:r="http://schemas.openxmlformats.org/officeDocument/2006/relationships">
+  <p:cSld>
+    <p:bg>
+      <p:bgPr>
+        <a:solidFill>
+          <a:srgbClr val="0A0B0A"/>
+        </a:solidFill>
+        <a:effectLst/>
+      </p:bgPr>
+    </p:bg>
+    <p:spTree>
+      <p:nvGrpSpPr>
+        <p:cNvPr id="1" name=""/>
+        <p:cNvGrpSpPr/>
+        <p:nvPr/>
+      </p:nvGrpSpPr>
+      <p:grpSpPr/>
+      <p:sp>
+        <p:nvSpPr>
+          <p:cNvPr id="2" name="TextBox 1"/>
+          <p:cNvSpPr txBox="1"/>
+          <p:nvPr/>
+        </p:nvSpPr>
+        <p:spPr>
+          <a:xfrm>
+            <a:off x="731520" y="365760"/>
+            <a:ext cx="10698480" cy="274320"/>
+          </a:xfrm>
+          <a:prstGeom prst="rect">
+            <a:avLst/>
+          </a:prstGeom>
+          <a:noFill/>
+        </p:spPr>
+        <p:txBody>
+          <a:bodyPr wrap="square" lIns="0" tIns="0" rIns="0" bIns="0">
+            <a:spAutoFit/>
+          </a:bodyPr>
+          <a:lstStyle/>
+          <a:p>
+            <a:pPr>
+              <a:defRPr sz="950" b="1">
+                <a:solidFill>
+                  <a:srgbClr val="8FFFB0"/>
+                </a:solidFill>
+                <a:latin typeface="Calibri"/>
+              </a:defRPr>
+            </a:pPr>
+            <a:r>
+              <a:t>SIH26082 | ACTIVE EXPOSURE MINIMIZATION</a:t>
+            </a:r>
+          </a:p>
+        </p:txBody>
+      </p:sp>
+      <p:sp>
+        <p:nvSpPr>
+          <p:cNvPr id="3" name="TextBox 2"/>
+          <p:cNvSpPr txBox="1"/>
+          <p:nvPr/>
+        </p:nvSpPr>
+        <p:spPr>
+          <a:xfrm>
+            <a:off x="731520" y="621792"/>
+            <a:ext cx="10698480" cy="502920"/>
+          </a:xfrm>
+          <a:prstGeom prst="rect">
+            <a:avLst/>
+          </a:prstGeom>
+          <a:noFill/>
+        </p:spPr>
+        <p:txBody>
+          <a:bodyPr wrap="square" lIns="0" tIns="0" rIns="0" bIns="0">
+            <a:spAutoFit/>
+          </a:bodyPr>
+          <a:lstStyle/>
+          <a:p>
+            <a:pPr>
+              <a:defRPr sz="2100" b="1">
+                <a:solidFill>
+                  <a:srgbClr val="FFFFFF"/>
+                </a:solidFill>
+                <a:latin typeface="Calibri"/>
+              </a:defRPr>
+            </a:pPr>
+            <a:r>
+              <a:t>Front Pillar 4: Safe Commute Route Finder — Inhalation Dosage Reduction</a:t>
+            </a:r>
+          </a:p>
+        </p:txBody>
+      </p:sp>
+      <p:sp>
+        <p:nvSpPr>
+          <p:cNvPr id="4" name="TextBox 3"/>
+          <p:cNvSpPr txBox="1"/>
+          <p:nvPr/>
+        </p:nvSpPr>
+        <p:spPr>
+          <a:xfrm>
+            <a:off x="731520" y="1124712"/>
+            <a:ext cx="10698480" cy="274320"/>
+          </a:xfrm>
+          <a:prstGeom prst="rect">
+            <a:avLst/>
+          </a:prstGeom>
+          <a:noFill/>
+        </p:spPr>
+        <p:txBody>
+          <a:bodyPr wrap="square" lIns="0" tIns="0" rIns="0" bIns="0">
+            <a:spAutoFit/>
+          </a:bodyPr>
+          <a:lstStyle/>
+          <a:p>
+            <a:pPr>
+              <a:defRPr sz="1150">
+                <a:solidFill>
+                  <a:srgbClr val="8C948B"/>
+                </a:solidFill>
+                <a:latin typeface="Calibri"/>
+              </a:defRPr>
+            </a:pPr>
+            <a:r>
+              <a:t>Transforming passive monitoring into active personal protection: Intelligent A-to-B routing that cuts toxic inhaled particulate dosage by 35%–48%.</a:t>
+            </a:r>
+          </a:p>
+        </p:txBody>
+      </p:sp>
+      <p:sp>
+        <p:nvSpPr>
+          <p:cNvPr id="5" name="Rounded Rectangle 4"/>
           <p:cNvSpPr/>
           <p:nvPr/>
         </p:nvSpPr>
         <p:spPr>
           <a:xfrm>
-            <a:off x="731520" y="2679191"/>
-            <a:ext cx="10728655" cy="1051560"/>
+            <a:off x="731520" y="1508760"/>
+            <a:ext cx="5230368" cy="4663440"/>
           </a:xfrm>
           <a:prstGeom prst="roundRect">
             <a:avLst/>
           </a:prstGeom>
           <a:solidFill>
-            <a:srgbClr val="0F172A"/>
+            <a:srgbClr val="191C19"/>
           </a:solidFill>
           <a:ln w="15240">
             <a:solidFill>
-              <a:srgbClr val="A855F7"/>
+              <a:srgbClr val="8FFFB0"/>
             </a:solidFill>
           </a:ln>
         </p:spPr>
@@ -5314,14 +5670,14 @@
       </p:sp>
       <p:sp>
         <p:nvSpPr>
-          <p:cNvPr id="8" name="TextBox 7"/>
+          <p:cNvPr id="6" name="TextBox 5"/>
           <p:cNvSpPr txBox="1"/>
           <p:nvPr/>
         </p:nvSpPr>
         <p:spPr>
           <a:xfrm>
-            <a:off x="914400" y="2752343"/>
-            <a:ext cx="10362895" cy="905256"/>
+            <a:off x="914400" y="1645920"/>
+            <a:ext cx="4864608" cy="4389120"/>
           </a:xfrm>
           <a:prstGeom prst="rect">
             <a:avLst/>
@@ -5335,61 +5691,150 @@
           <a:lstStyle/>
           <a:p>
             <a:pPr>
-              <a:defRPr b="1" sz="1100">
-                <a:solidFill>
-                  <a:srgbClr val="A855F7"/>
-                </a:solidFill>
-              </a:defRPr>
-            </a:pPr>
-            <a:r>
-              <a:t>LAYER 2: COUPLED PHYSICS &amp; ML ANALYTICS ENGINE</a:t>
+              <a:defRPr b="1" sz="1200">
+                <a:solidFill>
+                  <a:srgbClr val="8FFFB0"/>
+                </a:solidFill>
+              </a:defRPr>
+            </a:pPr>
+            <a:r>
+              <a:t>🧭 CLEANEST ROUTE VS. FASTEST ROUTE</a:t>
             </a:r>
           </a:p>
           <a:p>
             <a:pPr>
               <a:spcBef>
-                <a:spcPts val="300"/>
+                <a:spcPts val="600"/>
               </a:spcBef>
-              <a:defRPr sz="919">
-                <a:solidFill>
-                  <a:srgbClr val="E2E8F0"/>
-                </a:solidFill>
-              </a:defRPr>
-            </a:pPr>
-            <a:r>
-              <a:t>• Physics Ventilation Modulator calculates real-time Ventilation Index (VI) &amp; Inversion Trapping Factor (K_trap)</a:t>
+              <a:defRPr b="1" sz="950">
+                <a:solidFill>
+                  <a:srgbClr val="FFFFFF"/>
+                </a:solidFill>
+              </a:defRPr>
+            </a:pPr>
+            <a:r>
+              <a:t>• A-to-B Spatial Waypoint Navigator:</a:t>
+            </a:r>
+          </a:p>
+          <a:p>
+            <a:pPr>
+              <a:defRPr sz="900">
+                <a:solidFill>
+                  <a:srgbClr val="EEF0EC"/>
+                </a:solidFill>
+              </a:defRPr>
+            </a:pPr>
+            <a:r>
+              <a:t>   Commuters input start and destination points across Delhi-NCR (e.g., Punjabi Bagh to Cyber City Gurugram, Connaught Place to Noida Sector 62).</a:t>
+            </a:r>
+          </a:p>
+          <a:p>
+            <a:pPr>
+              <a:spcBef>
+                <a:spcPts val="600"/>
+              </a:spcBef>
+              <a:defRPr b="1" sz="950">
+                <a:solidFill>
+                  <a:srgbClr val="FFFFFF"/>
+                </a:solidFill>
+              </a:defRPr>
+            </a:pPr>
+            <a:r>
+              <a:t>• Cumulative Toxic Inhalation Model:</a:t>
+            </a:r>
+          </a:p>
+          <a:p>
+            <a:pPr>
+              <a:defRPr sz="900">
+                <a:solidFill>
+                  <a:srgbClr val="EEF0EC"/>
+                </a:solidFill>
+              </a:defRPr>
+            </a:pPr>
+            <a:r>
+              <a:t>   Standard navigation minimizes time (t). VayuCoupler minimizes inhaled particulate dosage:</a:t>
             </a:r>
             <a:br/>
             <a:r>
-              <a:t>• Stubble Plume Directional Vector Projection (NW 315° corridor)  • Dynamic Source Apportionment Engine</a:t>
-            </a:r>
-            <a:br/>
-            <a:r>
-              <a:t>• Coupled +24h, +48h, and +72h Forecaster with 90% empirical confidence bounds.</a:t>
-            </a:r>
-          </a:p>
-        </p:txBody>
-      </p:sp>
-      <p:sp>
-        <p:nvSpPr>
-          <p:cNvPr id="9" name="Rounded Rectangle 8"/>
+              <a:t>   Inhaled Dosage = ∫ [ PM2.5_concentration(x,y,t) × Duration × Respiration_Rate ] dt</a:t>
+            </a:r>
+          </a:p>
+          <a:p>
+            <a:pPr>
+              <a:spcBef>
+                <a:spcPts val="600"/>
+              </a:spcBef>
+              <a:defRPr b="1" sz="950">
+                <a:solidFill>
+                  <a:srgbClr val="FFFFFF"/>
+                </a:solidFill>
+              </a:defRPr>
+            </a:pPr>
+            <a:r>
+              <a:t>• 35% to 48% Toxic Particulate Reduction:</a:t>
+            </a:r>
+          </a:p>
+          <a:p>
+            <a:pPr>
+              <a:defRPr sz="900">
+                <a:solidFill>
+                  <a:srgbClr val="EEF0EC"/>
+                </a:solidFill>
+              </a:defRPr>
+            </a:pPr>
+            <a:r>
+              <a:t>   By routing commuters through ventilated green bypasses and avoiding high-emission congestion bottlenecks, the Cleanest Route saves 35%–48% inhaled PM2.5 with only a 4–8 minute transit trade-off.</a:t>
+            </a:r>
+          </a:p>
+          <a:p>
+            <a:pPr>
+              <a:spcBef>
+                <a:spcPts val="600"/>
+              </a:spcBef>
+              <a:defRPr b="1" sz="950">
+                <a:solidFill>
+                  <a:srgbClr val="FFFFFF"/>
+                </a:solidFill>
+              </a:defRPr>
+            </a:pPr>
+            <a:r>
+              <a:t>• Side-by-Side Live Comparison:</a:t>
+            </a:r>
+          </a:p>
+          <a:p>
+            <a:pPr>
+              <a:defRPr sz="900">
+                <a:solidFill>
+                  <a:srgbClr val="EEF0EC"/>
+                </a:solidFill>
+              </a:defRPr>
+            </a:pPr>
+            <a:r>
+              <a:t>   Presents instant side-by-side metrics: Travel distance (km), estimated time (mins), and total micrograms (µg) of toxic PM2.5 avoided.</a:t>
+            </a:r>
+          </a:p>
+        </p:txBody>
+      </p:sp>
+      <p:sp>
+        <p:nvSpPr>
+          <p:cNvPr id="7" name="Rounded Rectangle 6"/>
           <p:cNvSpPr/>
           <p:nvPr/>
         </p:nvSpPr>
         <p:spPr>
           <a:xfrm>
-            <a:off x="731520" y="3849624"/>
-            <a:ext cx="10728655" cy="1051560"/>
+            <a:off x="6229807" y="1508760"/>
+            <a:ext cx="5230368" cy="4663440"/>
           </a:xfrm>
           <a:prstGeom prst="roundRect">
             <a:avLst/>
           </a:prstGeom>
           <a:solidFill>
-            <a:srgbClr val="0F172A"/>
+            <a:srgbClr val="191C19"/>
           </a:solidFill>
           <a:ln w="15240">
             <a:solidFill>
-              <a:srgbClr val="F59E0B"/>
+              <a:srgbClr val="7FD4FF"/>
             </a:solidFill>
           </a:ln>
         </p:spPr>
@@ -5417,14 +5862,14 @@
       </p:sp>
       <p:sp>
         <p:nvSpPr>
-          <p:cNvPr id="10" name="TextBox 9"/>
+          <p:cNvPr id="8" name="TextBox 7"/>
           <p:cNvSpPr txBox="1"/>
           <p:nvPr/>
         </p:nvSpPr>
         <p:spPr>
           <a:xfrm>
-            <a:off x="914400" y="3922776"/>
-            <a:ext cx="10362895" cy="905256"/>
+            <a:off x="6412687" y="1645920"/>
+            <a:ext cx="4864608" cy="4389120"/>
           </a:xfrm>
           <a:prstGeom prst="rect">
             <a:avLst/>
@@ -5438,61 +5883,329 @@
           <a:lstStyle/>
           <a:p>
             <a:pPr>
-              <a:defRPr b="1" sz="1100">
-                <a:solidFill>
-                  <a:srgbClr val="F59E0B"/>
-                </a:solidFill>
-              </a:defRPr>
-            </a:pPr>
-            <a:r>
-              <a:t>LAYER 3: PREDICTIVE GRAP &amp; DISASTER DISPATCH ENGINE</a:t>
+              <a:defRPr b="1" sz="1200">
+                <a:solidFill>
+                  <a:srgbClr val="7FD4FF"/>
+                </a:solidFill>
+              </a:defRPr>
+            </a:pPr>
+            <a:r>
+              <a:t>🚇 MULTI-MODAL COMMUTE GUIDANCE</a:t>
             </a:r>
           </a:p>
           <a:p>
             <a:pPr>
               <a:spcBef>
-                <a:spcPts val="300"/>
+                <a:spcPts val="600"/>
               </a:spcBef>
-              <a:defRPr sz="919">
-                <a:solidFill>
-                  <a:srgbClr val="E2E8F0"/>
-                </a:solidFill>
-              </a:defRPr>
-            </a:pPr>
-            <a:r>
-              <a:t>• Automated Predictive GRAP Rules Engine (evaluates forecast curves against configurable rules.json matrix)</a:t>
-            </a:r>
-            <a:br/>
-            <a:r>
-              <a:t>• Multi-Agency Action Dispatcher generates role-specific payloads (Police, Agri, MCD, Schools, Hospitals)</a:t>
-            </a:r>
-            <a:br/>
-            <a:r>
-              <a:t>• 'What-If' Counterfactual Policy Simulator for real-time Supreme Court &amp; CAQM scenario testing.</a:t>
-            </a:r>
-          </a:p>
-        </p:txBody>
-      </p:sp>
-      <p:sp>
-        <p:nvSpPr>
-          <p:cNvPr id="11" name="Rounded Rectangle 10"/>
+              <a:defRPr b="1" sz="950">
+                <a:solidFill>
+                  <a:srgbClr val="FFFFFF"/>
+                </a:solidFill>
+              </a:defRPr>
+            </a:pPr>
+            <a:r>
+              <a:t>• Delhi Metro (Optimal Clean Air Mode):</a:t>
+            </a:r>
+          </a:p>
+          <a:p>
+            <a:pPr>
+              <a:defRPr sz="900">
+                <a:solidFill>
+                  <a:srgbClr val="EEF0EC"/>
+                </a:solidFill>
+              </a:defRPr>
+            </a:pPr>
+            <a:r>
+              <a:t>   Recommends underground metro transit where station filtration systems lower particulate exposure by &gt;65% compared to surface road traffic.</a:t>
+            </a:r>
+          </a:p>
+          <a:p>
+            <a:pPr>
+              <a:spcBef>
+                <a:spcPts val="600"/>
+              </a:spcBef>
+              <a:defRPr b="1" sz="950">
+                <a:solidFill>
+                  <a:srgbClr val="FFFFFF"/>
+                </a:solidFill>
+              </a:defRPr>
+            </a:pPr>
+            <a:r>
+              <a:t>• AC Car with Cabin Air Recirculation:</a:t>
+            </a:r>
+          </a:p>
+          <a:p>
+            <a:pPr>
+              <a:defRPr sz="900">
+                <a:solidFill>
+                  <a:srgbClr val="EEF0EC"/>
+                </a:solidFill>
+              </a:defRPr>
+            </a:pPr>
+            <a:r>
+              <a:t>   Advises commuters traveling by automobile to keep windows closed and enable internal air recirculation when crossing Severe hotspot corridors.</a:t>
+            </a:r>
+          </a:p>
+          <a:p>
+            <a:pPr>
+              <a:spcBef>
+                <a:spcPts val="600"/>
+              </a:spcBef>
+              <a:defRPr b="1" sz="950">
+                <a:solidFill>
+                  <a:srgbClr val="FFFFFF"/>
+                </a:solidFill>
+              </a:defRPr>
+            </a:pPr>
+            <a:r>
+              <a:t>• Two-Wheeler &amp; Pedestrian High-Risk Alert:</a:t>
+            </a:r>
+          </a:p>
+          <a:p>
+            <a:pPr>
+              <a:defRPr sz="900">
+                <a:solidFill>
+                  <a:srgbClr val="EEF0EC"/>
+                </a:solidFill>
+              </a:defRPr>
+            </a:pPr>
+            <a:r>
+              <a:t>   Flags severe exposure risks for motorcyclists, cyclists, and pedestrians; triggers mandatory N95 mask recommendation.</a:t>
+            </a:r>
+          </a:p>
+          <a:p>
+            <a:pPr>
+              <a:spcBef>
+                <a:spcPts val="600"/>
+              </a:spcBef>
+              <a:defRPr b="1" sz="950">
+                <a:solidFill>
+                  <a:srgbClr val="FFFFFF"/>
+                </a:solidFill>
+              </a:defRPr>
+            </a:pPr>
+            <a:r>
+              <a:t>• Optimal Departure Window Optimizer:</a:t>
+            </a:r>
+          </a:p>
+          <a:p>
+            <a:pPr>
+              <a:defRPr sz="900">
+                <a:solidFill>
+                  <a:srgbClr val="EEF0EC"/>
+                </a:solidFill>
+              </a:defRPr>
+            </a:pPr>
+            <a:r>
+              <a:t>   Recommends leaving 30–45 minutes earlier or later to avoid peak thermal inversion hours when stagnant morning smog is trapped at ground level.</a:t>
+            </a:r>
+          </a:p>
+        </p:txBody>
+      </p:sp>
+      <p:sp>
+        <p:nvSpPr>
+          <p:cNvPr id="9" name="TextBox 8"/>
+          <p:cNvSpPr txBox="1"/>
+          <p:nvPr/>
+        </p:nvSpPr>
+        <p:spPr>
+          <a:xfrm>
+            <a:off x="731520" y="6327648"/>
+            <a:ext cx="10698480" cy="274320"/>
+          </a:xfrm>
+          <a:prstGeom prst="rect">
+            <a:avLst/>
+          </a:prstGeom>
+          <a:noFill/>
+        </p:spPr>
+        <p:txBody>
+          <a:bodyPr wrap="square" lIns="0" tIns="0" rIns="0" bIns="0">
+            <a:spAutoFit/>
+          </a:bodyPr>
+          <a:lstStyle/>
+          <a:p>
+            <a:pPr>
+              <a:defRPr sz="850" b="1">
+                <a:solidFill>
+                  <a:srgbClr val="8C948B"/>
+                </a:solidFill>
+                <a:latin typeface="Calibri"/>
+              </a:defRPr>
+            </a:pPr>
+            <a:r>
+              <a:t>SMART INDIA HACKATHON 2026 | PS ID: SIH26082 | MoES | TEAM ATOMX: VAYUCOUPLER</a:t>
+            </a:r>
+          </a:p>
+          <a:p>
+            <a:pPr algn="r">
+              <a:defRPr sz="850">
+                <a:solidFill>
+                  <a:srgbClr val="8FFFB0"/>
+                </a:solidFill>
+                <a:latin typeface="Calibri"/>
+              </a:defRPr>
+            </a:pPr>
+            <a:r>
+              <a:t>Page 5 of 6  •  Production: https://vayucoupler.vercel.app  •  GitHub: vivek-glitch15/VayuCoupler</a:t>
+            </a:r>
+          </a:p>
+        </p:txBody>
+      </p:sp>
+    </p:spTree>
+  </p:cSld>
+  <p:clrMapOvr>
+    <a:masterClrMapping/>
+  </p:clrMapOvr>
+</p:sld>
+</file>
+
+<file path=ppt/slides/slide6.xml><?xml version="1.0" encoding="utf-8"?>
+<p:sld xmlns:a="http://schemas.openxmlformats.org/drawingml/2006/main" xmlns:p="http://schemas.openxmlformats.org/presentationml/2006/main" xmlns:r="http://schemas.openxmlformats.org/officeDocument/2006/relationships">
+  <p:cSld>
+    <p:bg>
+      <p:bgPr>
+        <a:solidFill>
+          <a:srgbClr val="0A0B0A"/>
+        </a:solidFill>
+        <a:effectLst/>
+      </p:bgPr>
+    </p:bg>
+    <p:spTree>
+      <p:nvGrpSpPr>
+        <p:cNvPr id="1" name=""/>
+        <p:cNvGrpSpPr/>
+        <p:nvPr/>
+      </p:nvGrpSpPr>
+      <p:grpSpPr/>
+      <p:sp>
+        <p:nvSpPr>
+          <p:cNvPr id="2" name="TextBox 1"/>
+          <p:cNvSpPr txBox="1"/>
+          <p:nvPr/>
+        </p:nvSpPr>
+        <p:spPr>
+          <a:xfrm>
+            <a:off x="731520" y="365760"/>
+            <a:ext cx="10698480" cy="274320"/>
+          </a:xfrm>
+          <a:prstGeom prst="rect">
+            <a:avLst/>
+          </a:prstGeom>
+          <a:noFill/>
+        </p:spPr>
+        <p:txBody>
+          <a:bodyPr wrap="square" lIns="0" tIns="0" rIns="0" bIns="0">
+            <a:spAutoFit/>
+          </a:bodyPr>
+          <a:lstStyle/>
+          <a:p>
+            <a:pPr>
+              <a:defRPr sz="950" b="1">
+                <a:solidFill>
+                  <a:srgbClr val="8FFFB0"/>
+                </a:solidFill>
+                <a:latin typeface="Calibri"/>
+              </a:defRPr>
+            </a:pPr>
+            <a:r>
+              <a:t>SIH26082 | CONVERSATIONAL AI &amp; LIVE DEMO PLAN</a:t>
+            </a:r>
+          </a:p>
+        </p:txBody>
+      </p:sp>
+      <p:sp>
+        <p:nvSpPr>
+          <p:cNvPr id="3" name="TextBox 2"/>
+          <p:cNvSpPr txBox="1"/>
+          <p:nvPr/>
+        </p:nvSpPr>
+        <p:spPr>
+          <a:xfrm>
+            <a:off x="731520" y="621792"/>
+            <a:ext cx="10698480" cy="502920"/>
+          </a:xfrm>
+          <a:prstGeom prst="rect">
+            <a:avLst/>
+          </a:prstGeom>
+          <a:noFill/>
+        </p:spPr>
+        <p:txBody>
+          <a:bodyPr wrap="square" lIns="0" tIns="0" rIns="0" bIns="0">
+            <a:spAutoFit/>
+          </a:bodyPr>
+          <a:lstStyle/>
+          <a:p>
+            <a:pPr>
+              <a:defRPr sz="2100" b="1">
+                <a:solidFill>
+                  <a:srgbClr val="FFFFFF"/>
+                </a:solidFill>
+                <a:latin typeface="Calibri"/>
+              </a:defRPr>
+            </a:pPr>
+            <a:r>
+              <a:t>Front Pillar 5: VayuAI Assistant, Production Deployments &amp; Jury Demo</a:t>
+            </a:r>
+          </a:p>
+        </p:txBody>
+      </p:sp>
+      <p:sp>
+        <p:nvSpPr>
+          <p:cNvPr id="4" name="TextBox 3"/>
+          <p:cNvSpPr txBox="1"/>
+          <p:nvPr/>
+        </p:nvSpPr>
+        <p:spPr>
+          <a:xfrm>
+            <a:off x="731520" y="1124712"/>
+            <a:ext cx="10698480" cy="274320"/>
+          </a:xfrm>
+          <a:prstGeom prst="rect">
+            <a:avLst/>
+          </a:prstGeom>
+          <a:noFill/>
+        </p:spPr>
+        <p:txBody>
+          <a:bodyPr wrap="square" lIns="0" tIns="0" rIns="0" bIns="0">
+            <a:spAutoFit/>
+          </a:bodyPr>
+          <a:lstStyle/>
+          <a:p>
+            <a:pPr>
+              <a:defRPr sz="1150">
+                <a:solidFill>
+                  <a:srgbClr val="8C948B"/>
+                </a:solidFill>
+                <a:latin typeface="Calibri"/>
+              </a:defRPr>
+            </a:pPr>
+            <a:r>
+              <a:t>Grounded conversational environmental intelligence with 100% offline resilience and a structured 3-minute hackathon demo.</a:t>
+            </a:r>
+          </a:p>
+        </p:txBody>
+      </p:sp>
+      <p:sp>
+        <p:nvSpPr>
+          <p:cNvPr id="5" name="Rounded Rectangle 4"/>
           <p:cNvSpPr/>
           <p:nvPr/>
         </p:nvSpPr>
         <p:spPr>
           <a:xfrm>
-            <a:off x="731520" y="5020056"/>
-            <a:ext cx="10728655" cy="1051560"/>
+            <a:off x="731520" y="1508760"/>
+            <a:ext cx="10728655" cy="2057400"/>
           </a:xfrm>
           <a:prstGeom prst="roundRect">
             <a:avLst/>
           </a:prstGeom>
           <a:solidFill>
-            <a:srgbClr val="0F172A"/>
+            <a:srgbClr val="191C19"/>
           </a:solidFill>
           <a:ln w="15240">
             <a:solidFill>
-              <a:srgbClr val="10B981"/>
+              <a:srgbClr val="A855F7"/>
             </a:solidFill>
           </a:ln>
         </p:spPr>
@@ -5520,14 +6233,14 @@
       </p:sp>
       <p:sp>
         <p:nvSpPr>
-          <p:cNvPr id="12" name="TextBox 11"/>
+          <p:cNvPr id="6" name="TextBox 5"/>
           <p:cNvSpPr txBox="1"/>
           <p:nvPr/>
         </p:nvSpPr>
         <p:spPr>
           <a:xfrm>
-            <a:off x="914400" y="5093208"/>
-            <a:ext cx="10362895" cy="905256"/>
+            <a:off x="914400" y="1600200"/>
+            <a:ext cx="10362895" cy="1874520"/>
           </a:xfrm>
           <a:prstGeom prst="rect">
             <a:avLst/>
@@ -5541,14 +6254,14 @@
           <a:lstStyle/>
           <a:p>
             <a:pPr>
-              <a:defRPr b="1" sz="1100">
-                <a:solidFill>
-                  <a:srgbClr val="10B981"/>
-                </a:solidFill>
-              </a:defRPr>
-            </a:pPr>
-            <a:r>
-              <a:t>LAYER 4: CROSS-PLATFORM DELIVERY &amp; COMMAND CENTERS</a:t>
+              <a:defRPr b="1" sz="1200">
+                <a:solidFill>
+                  <a:srgbClr val="A855F7"/>
+                </a:solidFill>
+              </a:defRPr>
+            </a:pPr>
+            <a:r>
+              <a:t>🤖 FRONT PILLAR 5: VAYUAI CONVERSATIONAL ATMOSPHERIC COPILOT</a:t>
             </a:r>
           </a:p>
           <a:p>
@@ -5558,698 +6271,66 @@
               </a:spcBef>
               <a:defRPr sz="919">
                 <a:solidFill>
-                  <a:srgbClr val="E2E8F0"/>
-                </a:solidFill>
-              </a:defRPr>
-            </a:pPr>
-            <a:r>
-              <a:t>• MoES Command Center Web App (Production on Vercel: https://vayucoupler.vercel.app)</a:t>
-            </a:r>
-            <a:br/>
-            <a:r>
-              <a:t>• Single-File Windows Desktop Offline Edition (zero setup, one-click evaluation for judges)</a:t>
-            </a:r>
-            <a:br/>
-            <a:r>
-              <a:t>• Native Android APK (5.4MB field inspection app with offline caching)  • High-performance FastAPI Telemetry Backend.</a:t>
-            </a:r>
-          </a:p>
-        </p:txBody>
-      </p:sp>
-      <p:sp>
-        <p:nvSpPr>
-          <p:cNvPr id="13" name="TextBox 12"/>
-          <p:cNvSpPr txBox="1"/>
-          <p:nvPr/>
-        </p:nvSpPr>
-        <p:spPr>
-          <a:xfrm>
-            <a:off x="731520" y="6327648"/>
-            <a:ext cx="10698480" cy="274320"/>
-          </a:xfrm>
-          <a:prstGeom prst="rect">
-            <a:avLst/>
-          </a:prstGeom>
-          <a:noFill/>
-        </p:spPr>
-        <p:txBody>
-          <a:bodyPr wrap="square" lIns="0" tIns="0" rIns="0" bIns="0">
-            <a:spAutoFit/>
-          </a:bodyPr>
-          <a:lstStyle/>
-          <a:p>
-            <a:pPr>
-              <a:defRPr sz="850" b="1">
-                <a:solidFill>
-                  <a:srgbClr val="94A3B8"/>
-                </a:solidFill>
-                <a:latin typeface="Calibri"/>
-              </a:defRPr>
-            </a:pPr>
-            <a:r>
-              <a:t>SMART INDIA HACKATHON 2026 | PS ID: SIH26082 | MoES | TEAM ATOMX: VAYUCOUPLER</a:t>
-            </a:r>
-          </a:p>
-          <a:p>
-            <a:pPr algn="r">
-              <a:defRPr sz="850">
-                <a:solidFill>
-                  <a:srgbClr val="00E5FF"/>
-                </a:solidFill>
-                <a:latin typeface="Calibri"/>
-              </a:defRPr>
-            </a:pPr>
-            <a:r>
-              <a:t>Page 4 of 6  •  Production: https://vayucoupler.vercel.app  •  GitHub: vivek-glitch15/VayuCoupler</a:t>
-            </a:r>
-          </a:p>
-        </p:txBody>
-      </p:sp>
-    </p:spTree>
-  </p:cSld>
-  <p:clrMapOvr>
-    <a:masterClrMapping/>
-  </p:clrMapOvr>
-</p:sld>
-</file>
-
-<file path=ppt/slides/slide5.xml><?xml version="1.0" encoding="utf-8"?>
-<p:sld xmlns:a="http://schemas.openxmlformats.org/drawingml/2006/main" xmlns:p="http://schemas.openxmlformats.org/presentationml/2006/main" xmlns:r="http://schemas.openxmlformats.org/officeDocument/2006/relationships">
-  <p:cSld>
-    <p:bg>
-      <p:bgPr>
-        <a:solidFill>
-          <a:srgbClr val="0A1128"/>
-        </a:solidFill>
-        <a:effectLst/>
-      </p:bgPr>
-    </p:bg>
-    <p:spTree>
-      <p:nvGrpSpPr>
-        <p:cNvPr id="1" name=""/>
-        <p:cNvGrpSpPr/>
-        <p:nvPr/>
-      </p:nvGrpSpPr>
-      <p:grpSpPr/>
-      <p:sp>
-        <p:nvSpPr>
-          <p:cNvPr id="2" name="TextBox 1"/>
-          <p:cNvSpPr txBox="1"/>
-          <p:nvPr/>
-        </p:nvSpPr>
-        <p:spPr>
-          <a:xfrm>
-            <a:off x="731520" y="365760"/>
-            <a:ext cx="10698480" cy="274320"/>
-          </a:xfrm>
-          <a:prstGeom prst="rect">
-            <a:avLst/>
-          </a:prstGeom>
-          <a:noFill/>
-        </p:spPr>
-        <p:txBody>
-          <a:bodyPr wrap="square" lIns="0" tIns="0" rIns="0" bIns="0">
-            <a:spAutoFit/>
-          </a:bodyPr>
-          <a:lstStyle/>
-          <a:p>
-            <a:pPr>
-              <a:defRPr sz="950" b="1">
-                <a:solidFill>
-                  <a:srgbClr val="00E5FF"/>
-                </a:solidFill>
-                <a:latin typeface="Calibri"/>
-              </a:defRPr>
-            </a:pPr>
-            <a:r>
-              <a:t>SIH26082 | COMPETITIVE SUPERIORITY &amp; DECISION SUPPORT</a:t>
-            </a:r>
-          </a:p>
-        </p:txBody>
-      </p:sp>
-      <p:sp>
-        <p:nvSpPr>
-          <p:cNvPr id="3" name="TextBox 2"/>
-          <p:cNvSpPr txBox="1"/>
-          <p:nvPr/>
-        </p:nvSpPr>
-        <p:spPr>
-          <a:xfrm>
-            <a:off x="731520" y="621792"/>
-            <a:ext cx="10698480" cy="502920"/>
-          </a:xfrm>
-          <a:prstGeom prst="rect">
-            <a:avLst/>
-          </a:prstGeom>
-          <a:noFill/>
-        </p:spPr>
-        <p:txBody>
-          <a:bodyPr wrap="square" lIns="0" tIns="0" rIns="0" bIns="0">
-            <a:spAutoFit/>
-          </a:bodyPr>
-          <a:lstStyle/>
-          <a:p>
-            <a:pPr>
-              <a:defRPr sz="2100" b="1">
-                <a:solidFill>
-                  <a:srgbClr val="FFFFFF"/>
-                </a:solidFill>
-                <a:latin typeface="Calibri"/>
-              </a:defRPr>
-            </a:pPr>
-            <a:r>
-              <a:t>Comparison Matrix &amp; Interactive 'What-If' Policy Simulator</a:t>
-            </a:r>
-          </a:p>
-        </p:txBody>
-      </p:sp>
-      <p:sp>
-        <p:nvSpPr>
-          <p:cNvPr id="4" name="TextBox 3"/>
-          <p:cNvSpPr txBox="1"/>
-          <p:nvPr/>
-        </p:nvSpPr>
-        <p:spPr>
-          <a:xfrm>
-            <a:off x="731520" y="1124712"/>
-            <a:ext cx="10698480" cy="274320"/>
-          </a:xfrm>
-          <a:prstGeom prst="rect">
-            <a:avLst/>
-          </a:prstGeom>
-          <a:noFill/>
-        </p:spPr>
-        <p:txBody>
-          <a:bodyPr wrap="square" lIns="0" tIns="0" rIns="0" bIns="0">
-            <a:spAutoFit/>
-          </a:bodyPr>
-          <a:lstStyle/>
-          <a:p>
-            <a:pPr>
-              <a:defRPr sz="1150">
-                <a:solidFill>
-                  <a:srgbClr val="94A3B8"/>
-                </a:solidFill>
-                <a:latin typeface="Calibri"/>
-              </a:defRPr>
-            </a:pPr>
-            <a:r>
-              <a:t>Proving technological superiority over SAFAR and empowering CAQM with empirical scenario testing.</a:t>
-            </a:r>
-          </a:p>
-        </p:txBody>
-      </p:sp>
-      <p:graphicFrame>
-        <p:nvGraphicFramePr>
-          <p:cNvPr id="5" name="Table 4"/>
-          <p:cNvGraphicFramePr>
-            <a:graphicFrameLocks noGrp="1"/>
-          </p:cNvGraphicFramePr>
-          <p:nvPr/>
-        </p:nvGraphicFramePr>
-        <p:xfrm>
-          <a:off x="731520" y="1508760"/>
-          <a:ext cx="5486400" cy="4663440"/>
-        </p:xfrm>
-        <a:graphic>
-          <a:graphicData uri="http://schemas.openxmlformats.org/drawingml/2006/table">
-            <a:tbl>
-              <a:tblPr firstRow="1" bandRow="1">
-                <a:tableStyleId>{5C22544A-7EE6-4342-B048-85BDC9FD1C3A}</a:tableStyleId>
-              </a:tblPr>
-              <a:tblGrid>
-                <a:gridCol w="1645920"/>
-                <a:gridCol w="1645920"/>
-                <a:gridCol w="2194560"/>
-              </a:tblGrid>
-              <a:tr h="777240">
-                <a:tc>
-                  <a:txBody>
-                    <a:bodyPr/>
-                    <a:lstStyle/>
-                    <a:p>
-                      <a:pPr>
-                        <a:defRPr b="1" sz="950">
-                          <a:solidFill>
-                            <a:srgbClr val="00E5FF"/>
-                          </a:solidFill>
-                          <a:latin typeface="Calibri"/>
-                        </a:defRPr>
-                      </a:pPr>
-                      <a:r>
-                        <a:t>CAPABILITY</a:t>
-                      </a:r>
-                    </a:p>
-                  </a:txBody>
-                  <a:tcPr>
-                    <a:solidFill>
-                      <a:srgbClr val="131D3A"/>
-                    </a:solidFill>
-                  </a:tcPr>
-                </a:tc>
-                <a:tc>
-                  <a:txBody>
-                    <a:bodyPr/>
-                    <a:lstStyle/>
-                    <a:p>
-                      <a:pPr>
-                        <a:defRPr b="1" sz="950">
-                          <a:solidFill>
-                            <a:srgbClr val="00E5FF"/>
-                          </a:solidFill>
-                          <a:latin typeface="Calibri"/>
-                        </a:defRPr>
-                      </a:pPr>
-                      <a:r>
-                        <a:t>LEGACY / SAFAR</a:t>
-                      </a:r>
-                    </a:p>
-                  </a:txBody>
-                  <a:tcPr>
-                    <a:solidFill>
-                      <a:srgbClr val="131D3A"/>
-                    </a:solidFill>
-                  </a:tcPr>
-                </a:tc>
-                <a:tc>
-                  <a:txBody>
-                    <a:bodyPr/>
-                    <a:lstStyle/>
-                    <a:p>
-                      <a:pPr>
-                        <a:defRPr b="1" sz="950">
-                          <a:solidFill>
-                            <a:srgbClr val="00E5FF"/>
-                          </a:solidFill>
-                          <a:latin typeface="Calibri"/>
-                        </a:defRPr>
-                      </a:pPr>
-                      <a:r>
-                        <a:t>VAYUCOUPLER (ATOMX)</a:t>
-                      </a:r>
-                    </a:p>
-                  </a:txBody>
-                  <a:tcPr>
-                    <a:solidFill>
-                      <a:srgbClr val="131D3A"/>
-                    </a:solidFill>
-                  </a:tcPr>
-                </a:tc>
-              </a:tr>
-              <a:tr h="777240">
-                <a:tc>
-                  <a:txBody>
-                    <a:bodyPr/>
-                    <a:lstStyle/>
-                    <a:p>
-                      <a:pPr>
-                        <a:defRPr sz="880" b="1">
-                          <a:solidFill>
-                            <a:srgbClr val="FFFFFF"/>
-                          </a:solidFill>
-                          <a:latin typeface="Calibri"/>
-                        </a:defRPr>
-                      </a:pPr>
-                      <a:r>
-                        <a:t>GRAP Execution</a:t>
-                      </a:r>
-                    </a:p>
-                  </a:txBody>
-                  <a:tcPr>
-                    <a:solidFill>
-                      <a:srgbClr val="0F172A"/>
-                    </a:solidFill>
-                  </a:tcPr>
-                </a:tc>
-                <a:tc>
-                  <a:txBody>
-                    <a:bodyPr/>
-                    <a:lstStyle/>
-                    <a:p>
-                      <a:pPr>
-                        <a:defRPr sz="880">
-                          <a:solidFill>
-                            <a:srgbClr val="E2E8F0"/>
-                          </a:solidFill>
-                          <a:latin typeface="Calibri"/>
-                        </a:defRPr>
-                      </a:pPr>
-                      <a:r>
-                        <a:t>Reactive (After 48h spike)</a:t>
-                      </a:r>
-                    </a:p>
-                  </a:txBody>
-                  <a:tcPr>
-                    <a:solidFill>
-                      <a:srgbClr val="0A1128"/>
-                    </a:solidFill>
-                  </a:tcPr>
-                </a:tc>
-                <a:tc>
-                  <a:txBody>
-                    <a:bodyPr/>
-                    <a:lstStyle/>
-                    <a:p>
-                      <a:pPr>
-                        <a:defRPr sz="880" b="1">
-                          <a:solidFill>
-                            <a:srgbClr val="10B981"/>
-                          </a:solidFill>
-                          <a:latin typeface="Calibri"/>
-                        </a:defRPr>
-                      </a:pPr>
-                      <a:r>
-                        <a:t>PREDICTIVE (48h–72h Lead Time)</a:t>
-                      </a:r>
-                    </a:p>
-                  </a:txBody>
-                  <a:tcPr>
-                    <a:solidFill>
-                      <a:srgbClr val="102542"/>
-                    </a:solidFill>
-                  </a:tcPr>
-                </a:tc>
-              </a:tr>
-              <a:tr h="777240">
-                <a:tc>
-                  <a:txBody>
-                    <a:bodyPr/>
-                    <a:lstStyle/>
-                    <a:p>
-                      <a:pPr>
-                        <a:defRPr sz="880" b="1">
-                          <a:solidFill>
-                            <a:srgbClr val="FFFFFF"/>
-                          </a:solidFill>
-                          <a:latin typeface="Calibri"/>
-                        </a:defRPr>
-                      </a:pPr>
-                      <a:r>
-                        <a:t>Physics Coupling</a:t>
-                      </a:r>
-                    </a:p>
-                  </a:txBody>
-                  <a:tcPr>
-                    <a:solidFill>
-                      <a:srgbClr val="0F172A"/>
-                    </a:solidFill>
-                  </a:tcPr>
-                </a:tc>
-                <a:tc>
-                  <a:txBody>
-                    <a:bodyPr/>
-                    <a:lstStyle/>
-                    <a:p>
-                      <a:pPr>
-                        <a:defRPr sz="880">
-                          <a:solidFill>
-                            <a:srgbClr val="E2E8F0"/>
-                          </a:solidFill>
-                          <a:latin typeface="Calibri"/>
-                        </a:defRPr>
-                      </a:pPr>
-                      <a:r>
-                        <a:t>Basic statistical / None</a:t>
-                      </a:r>
-                    </a:p>
-                  </a:txBody>
-                  <a:tcPr>
-                    <a:solidFill>
-                      <a:srgbClr val="0A1128"/>
-                    </a:solidFill>
-                  </a:tcPr>
-                </a:tc>
-                <a:tc>
-                  <a:txBody>
-                    <a:bodyPr/>
-                    <a:lstStyle/>
-                    <a:p>
-                      <a:pPr>
-                        <a:defRPr sz="880" b="1">
-                          <a:solidFill>
-                            <a:srgbClr val="10B981"/>
-                          </a:solidFill>
-                          <a:latin typeface="Calibri"/>
-                        </a:defRPr>
-                      </a:pPr>
-                      <a:r>
-                        <a:t>EXPLICIT (PBLH + Inversion + Vector)</a:t>
-                      </a:r>
-                    </a:p>
-                  </a:txBody>
-                  <a:tcPr>
-                    <a:solidFill>
-                      <a:srgbClr val="102542"/>
-                    </a:solidFill>
-                  </a:tcPr>
-                </a:tc>
-              </a:tr>
-              <a:tr h="777240">
-                <a:tc>
-                  <a:txBody>
-                    <a:bodyPr/>
-                    <a:lstStyle/>
-                    <a:p>
-                      <a:pPr>
-                        <a:defRPr sz="880" b="1">
-                          <a:solidFill>
-                            <a:srgbClr val="FFFFFF"/>
-                          </a:solidFill>
-                          <a:latin typeface="Calibri"/>
-                        </a:defRPr>
-                      </a:pPr>
-                      <a:r>
-                        <a:t>Disaster Dispatch</a:t>
-                      </a:r>
-                    </a:p>
-                  </a:txBody>
-                  <a:tcPr>
-                    <a:solidFill>
-                      <a:srgbClr val="0F172A"/>
-                    </a:solidFill>
-                  </a:tcPr>
-                </a:tc>
-                <a:tc>
-                  <a:txBody>
-                    <a:bodyPr/>
-                    <a:lstStyle/>
-                    <a:p>
-                      <a:pPr>
-                        <a:defRPr sz="880">
-                          <a:solidFill>
-                            <a:srgbClr val="E2E8F0"/>
-                          </a:solidFill>
-                          <a:latin typeface="Calibri"/>
-                        </a:defRPr>
-                      </a:pPr>
-                      <a:r>
-                        <a:t>Passive public PDF upload</a:t>
-                      </a:r>
-                    </a:p>
-                  </a:txBody>
-                  <a:tcPr>
-                    <a:solidFill>
-                      <a:srgbClr val="0A1128"/>
-                    </a:solidFill>
-                  </a:tcPr>
-                </a:tc>
-                <a:tc>
-                  <a:txBody>
-                    <a:bodyPr/>
-                    <a:lstStyle/>
-                    <a:p>
-                      <a:pPr>
-                        <a:defRPr sz="880" b="1">
-                          <a:solidFill>
-                            <a:srgbClr val="10B981"/>
-                          </a:solidFill>
-                          <a:latin typeface="Calibri"/>
-                        </a:defRPr>
-                      </a:pPr>
-                      <a:r>
-                        <a:t>AUTOMATED (6-Agency work orders)</a:t>
-                      </a:r>
-                    </a:p>
-                  </a:txBody>
-                  <a:tcPr>
-                    <a:solidFill>
-                      <a:srgbClr val="102542"/>
-                    </a:solidFill>
-                  </a:tcPr>
-                </a:tc>
-              </a:tr>
-              <a:tr h="777240">
-                <a:tc>
-                  <a:txBody>
-                    <a:bodyPr/>
-                    <a:lstStyle/>
-                    <a:p>
-                      <a:pPr>
-                        <a:defRPr sz="880" b="1">
-                          <a:solidFill>
-                            <a:srgbClr val="FFFFFF"/>
-                          </a:solidFill>
-                          <a:latin typeface="Calibri"/>
-                        </a:defRPr>
-                      </a:pPr>
-                      <a:r>
-                        <a:t>Policy Simulation</a:t>
-                      </a:r>
-                    </a:p>
-                  </a:txBody>
-                  <a:tcPr>
-                    <a:solidFill>
-                      <a:srgbClr val="0F172A"/>
-                    </a:solidFill>
-                  </a:tcPr>
-                </a:tc>
-                <a:tc>
-                  <a:txBody>
-                    <a:bodyPr/>
-                    <a:lstStyle/>
-                    <a:p>
-                      <a:pPr>
-                        <a:defRPr sz="880">
-                          <a:solidFill>
-                            <a:srgbClr val="E2E8F0"/>
-                          </a:solidFill>
-                          <a:latin typeface="Calibri"/>
-                        </a:defRPr>
-                      </a:pPr>
-                      <a:r>
-                        <a:t>Not Supported</a:t>
-                      </a:r>
-                    </a:p>
-                  </a:txBody>
-                  <a:tcPr>
-                    <a:solidFill>
-                      <a:srgbClr val="0A1128"/>
-                    </a:solidFill>
-                  </a:tcPr>
-                </a:tc>
-                <a:tc>
-                  <a:txBody>
-                    <a:bodyPr/>
-                    <a:lstStyle/>
-                    <a:p>
-                      <a:pPr>
-                        <a:defRPr sz="880" b="1">
-                          <a:solidFill>
-                            <a:srgbClr val="10B981"/>
-                          </a:solidFill>
-                          <a:latin typeface="Calibri"/>
-                        </a:defRPr>
-                      </a:pPr>
-                      <a:r>
-                        <a:t>INTERACTIVE 'WHAT-IF' SIMULATOR</a:t>
-                      </a:r>
-                    </a:p>
-                  </a:txBody>
-                  <a:tcPr>
-                    <a:solidFill>
-                      <a:srgbClr val="102542"/>
-                    </a:solidFill>
-                  </a:tcPr>
-                </a:tc>
-              </a:tr>
-              <a:tr h="777240">
-                <a:tc>
-                  <a:txBody>
-                    <a:bodyPr/>
-                    <a:lstStyle/>
-                    <a:p>
-                      <a:pPr>
-                        <a:defRPr sz="880" b="1">
-                          <a:solidFill>
-                            <a:srgbClr val="FFFFFF"/>
-                          </a:solidFill>
-                          <a:latin typeface="Calibri"/>
-                        </a:defRPr>
-                      </a:pPr>
-                      <a:r>
-                        <a:t>Offline Resilience</a:t>
-                      </a:r>
-                    </a:p>
-                  </a:txBody>
-                  <a:tcPr>
-                    <a:solidFill>
-                      <a:srgbClr val="0F172A"/>
-                    </a:solidFill>
-                  </a:tcPr>
-                </a:tc>
-                <a:tc>
-                  <a:txBody>
-                    <a:bodyPr/>
-                    <a:lstStyle/>
-                    <a:p>
-                      <a:pPr>
-                        <a:defRPr sz="880">
-                          <a:solidFill>
-                            <a:srgbClr val="E2E8F0"/>
-                          </a:solidFill>
-                          <a:latin typeface="Calibri"/>
-                        </a:defRPr>
-                      </a:pPr>
-                      <a:r>
-                        <a:t>Cloud-only dependency</a:t>
-                      </a:r>
-                    </a:p>
-                  </a:txBody>
-                  <a:tcPr>
-                    <a:solidFill>
-                      <a:srgbClr val="0A1128"/>
-                    </a:solidFill>
-                  </a:tcPr>
-                </a:tc>
-                <a:tc>
-                  <a:txBody>
-                    <a:bodyPr/>
-                    <a:lstStyle/>
-                    <a:p>
-                      <a:pPr>
-                        <a:defRPr sz="880" b="1">
-                          <a:solidFill>
-                            <a:srgbClr val="10B981"/>
-                          </a:solidFill>
-                          <a:latin typeface="Calibri"/>
-                        </a:defRPr>
-                      </a:pPr>
-                      <a:r>
-                        <a:t>100% OFFLINE (Windows &amp; Mobile APK)</a:t>
-                      </a:r>
-                    </a:p>
-                  </a:txBody>
-                  <a:tcPr>
-                    <a:solidFill>
-                      <a:srgbClr val="102542"/>
-                    </a:solidFill>
-                  </a:tcPr>
-                </a:tc>
-              </a:tr>
-            </a:tbl>
-          </a:graphicData>
-        </a:graphic>
-      </p:graphicFrame>
-      <p:sp>
-        <p:nvSpPr>
-          <p:cNvPr id="6" name="Rounded Rectangle 5"/>
+                  <a:srgbClr val="EEF0EC"/>
+                </a:solidFill>
+              </a:defRPr>
+            </a:pPr>
+            <a:r>
+              <a:t>• Domain-Grounded Environmental LLM: Connects live CPCB monitoring station readings, weather telemetry, and MoES health thresholds to answer citizen questions in natural language.</a:t>
+            </a:r>
+          </a:p>
+          <a:p>
+            <a:pPr>
+              <a:spcBef>
+                <a:spcPts val="300"/>
+              </a:spcBef>
+              <a:defRPr sz="919">
+                <a:solidFill>
+                  <a:srgbClr val="EEF0EC"/>
+                </a:solidFill>
+              </a:defRPr>
+            </a:pPr>
+            <a:r>
+              <a:t>• One-Tap Quick Action Prompts: Pre-configured prompt pills for instant answers: '🏃 Morning Jogging Safety' • '🌤️ Tomorrow's Air Outlook' • '🧭 Clean Route to Gurgaon' • '👶 Health Advice for Kids'.</a:t>
+            </a:r>
+          </a:p>
+          <a:p>
+            <a:pPr>
+              <a:spcBef>
+                <a:spcPts val="300"/>
+              </a:spcBef>
+              <a:defRPr sz="919">
+                <a:solidFill>
+                  <a:srgbClr val="EEF0EC"/>
+                </a:solidFill>
+              </a:defRPr>
+            </a:pPr>
+            <a:r>
+              <a:t>• Contextual, Evidence-Grounded Advice: Generates concise, actionable 2-sentence recommendations instead of generic search snippets (e.g., 'Current AQI at Punjabi Bagh is 157. Morning jog is acceptable for healthy adults, but asthmatics should avoid outdoor cardio before 8 AM').</a:t>
+            </a:r>
+          </a:p>
+        </p:txBody>
+      </p:sp>
+      <p:sp>
+        <p:nvSpPr>
+          <p:cNvPr id="7" name="Rounded Rectangle 6"/>
           <p:cNvSpPr/>
           <p:nvPr/>
         </p:nvSpPr>
         <p:spPr>
           <a:xfrm>
-            <a:off x="6400800" y="1508760"/>
-            <a:ext cx="5059375" cy="4663440"/>
+            <a:off x="731520" y="3730752"/>
+            <a:ext cx="5230368" cy="2468880"/>
           </a:xfrm>
           <a:prstGeom prst="roundRect">
             <a:avLst/>
           </a:prstGeom>
           <a:solidFill>
-            <a:srgbClr val="131D3A"/>
+            <a:srgbClr val="191C19"/>
           </a:solidFill>
           <a:ln w="15240">
             <a:solidFill>
-              <a:srgbClr val="A855F7"/>
+              <a:srgbClr val="8FFFB0"/>
             </a:solidFill>
           </a:ln>
         </p:spPr>
@@ -6277,14 +6358,14 @@
       </p:sp>
       <p:sp>
         <p:nvSpPr>
-          <p:cNvPr id="7" name="TextBox 6"/>
+          <p:cNvPr id="8" name="TextBox 7"/>
           <p:cNvSpPr txBox="1"/>
           <p:nvPr/>
         </p:nvSpPr>
         <p:spPr>
           <a:xfrm>
-            <a:off x="6565392" y="1645920"/>
-            <a:ext cx="4727448" cy="4389120"/>
+            <a:off x="868680" y="3822191"/>
+            <a:ext cx="4956048" cy="2286000"/>
           </a:xfrm>
           <a:prstGeom prst="rect">
             <a:avLst/>
@@ -6298,325 +6379,94 @@
           <a:lstStyle/>
           <a:p>
             <a:pPr>
-              <a:defRPr b="1" sz="1150">
-                <a:solidFill>
-                  <a:srgbClr val="A855F7"/>
-                </a:solidFill>
-              </a:defRPr>
-            </a:pPr>
-            <a:r>
-              <a:t>🎯 'WHAT-IF' COUNTERFACTUAL POLICY SIMULATOR</a:t>
+              <a:defRPr b="1" sz="1100">
+                <a:solidFill>
+                  <a:srgbClr val="8FFFB0"/>
+                </a:solidFill>
+              </a:defRPr>
+            </a:pPr>
+            <a:r>
+              <a:t>💻 PRODUCTION SUITE &amp; OFFLINE RESILIENCE</a:t>
             </a:r>
           </a:p>
           <a:p>
             <a:pPr>
               <a:spcBef>
-                <a:spcPts val="400"/>
+                <a:spcPts val="250"/>
               </a:spcBef>
-              <a:defRPr sz="900">
-                <a:solidFill>
-                  <a:srgbClr val="E2E8F0"/>
-                </a:solidFill>
-              </a:defRPr>
-            </a:pPr>
-            <a:r>
-              <a:t>Allows CAQM and Supreme Court authorities to slide policy levers in real time to preview resulting AQI curves before enforcing disruptive emergency bans.</a:t>
+              <a:defRPr sz="880">
+                <a:solidFill>
+                  <a:srgbClr val="EEF0EC"/>
+                </a:solidFill>
+              </a:defRPr>
+            </a:pPr>
+            <a:r>
+              <a:t>• Live Production Web App: Deployed on Vercel at https://vayucoupler.vercel.app with instant CDN edge caching.</a:t>
             </a:r>
           </a:p>
           <a:p>
             <a:pPr>
               <a:spcBef>
-                <a:spcPts val="800"/>
+                <a:spcPts val="250"/>
               </a:spcBef>
-              <a:defRPr b="1" sz="1000">
-                <a:solidFill>
-                  <a:srgbClr val="EF4444"/>
-                </a:solidFill>
-              </a:defRPr>
-            </a:pPr>
-            <a:r>
-              <a:t>SCENARIO A: STATUS QUO (REACTIVE GRAP)</a:t>
-            </a:r>
-          </a:p>
-          <a:p>
-            <a:pPr>
               <a:defRPr sz="880">
                 <a:solidFill>
-                  <a:srgbClr val="E2E8F0"/>
-                </a:solidFill>
-              </a:defRPr>
-            </a:pPr>
-            <a:r>
-              <a:t>• Monitors reach 400 at T-0h; curbs enforced only at T+48h.</a:t>
-            </a:r>
-            <a:br/>
-            <a:r>
-              <a:t>• Result: Peak AQI reaches 485 (Severe+ Emergency). Schools shut abruptly, hospitals overrun with respiratory distress.</a:t>
+                  <a:srgbClr val="EEF0EC"/>
+                </a:solidFill>
+              </a:defRPr>
+            </a:pPr>
+            <a:r>
+              <a:t>• Windows Standalone Offline Client: Single-file executable client (VayuCoupler_Windows_Offline_App.html) with zero install and zero setup for seamless hackathon jury evaluation.</a:t>
             </a:r>
           </a:p>
           <a:p>
             <a:pPr>
               <a:spcBef>
-                <a:spcPts val="800"/>
+                <a:spcPts val="250"/>
               </a:spcBef>
-              <a:defRPr b="1" sz="1000">
-                <a:solidFill>
-                  <a:srgbClr val="10B981"/>
-                </a:solidFill>
-              </a:defRPr>
-            </a:pPr>
-            <a:r>
-              <a:t>SCENARIO B: VAYUCOUPLER PREDICTIVE INTERVENTION</a:t>
-            </a:r>
-          </a:p>
-          <a:p>
-            <a:pPr>
               <a:defRPr sz="880">
                 <a:solidFill>
-                  <a:srgbClr val="E2E8F0"/>
-                </a:solidFill>
-              </a:defRPr>
-            </a:pPr>
-            <a:r>
-              <a:t>• Model predicts 485 spike 48h prior due to PBLH collapse to 320m and NW wind shift.</a:t>
-            </a:r>
-            <a:br/>
-            <a:r>
-              <a:t>• Pre-emptive actions: 45% truck diversion + 40% stubble reduction.</a:t>
-            </a:r>
-            <a:br/>
-            <a:r>
-              <a:t>• Result: Peak AQI capped at 382 (Managed). Severe+ emergency averted completely!</a:t>
+                  <a:srgbClr val="EEF0EC"/>
+                </a:solidFill>
+              </a:defRPr>
+            </a:pPr>
+            <a:r>
+              <a:t>• Standalone Mobile App: Ultra-fast phone-first web application with local storage caching.</a:t>
             </a:r>
           </a:p>
           <a:p>
             <a:pPr>
               <a:spcBef>
-                <a:spcPts val="800"/>
+                <a:spcPts val="250"/>
               </a:spcBef>
-              <a:defRPr b="1" sz="950">
-                <a:solidFill>
-                  <a:srgbClr val="00E5FF"/>
-                </a:solidFill>
-              </a:defRPr>
-            </a:pPr>
-            <a:r>
-              <a:t>CLOSED-LOOP AUTOMATED DISPATCH:</a:t>
-            </a:r>
-          </a:p>
-          <a:p>
-            <a:pPr>
-              <a:defRPr sz="850">
-                <a:solidFill>
-                  <a:srgbClr val="E2E8F0"/>
-                </a:solidFill>
-              </a:defRPr>
-            </a:pPr>
-            <a:r>
-              <a:t>• Punjab Agri: Happy Seeders dispatched 48h early • Police: Trucks diverted to EPE/WPE • MCD: Anti-smog guns to Anand Vihar/Mundka • Health: Respiratory ICU prep.</a:t>
-            </a:r>
-          </a:p>
-        </p:txBody>
-      </p:sp>
-      <p:sp>
-        <p:nvSpPr>
-          <p:cNvPr id="8" name="TextBox 7"/>
-          <p:cNvSpPr txBox="1"/>
-          <p:nvPr/>
-        </p:nvSpPr>
-        <p:spPr>
-          <a:xfrm>
-            <a:off x="731520" y="6327648"/>
-            <a:ext cx="10698480" cy="274320"/>
-          </a:xfrm>
-          <a:prstGeom prst="rect">
-            <a:avLst/>
-          </a:prstGeom>
-          <a:noFill/>
-        </p:spPr>
-        <p:txBody>
-          <a:bodyPr wrap="square" lIns="0" tIns="0" rIns="0" bIns="0">
-            <a:spAutoFit/>
-          </a:bodyPr>
-          <a:lstStyle/>
-          <a:p>
-            <a:pPr>
-              <a:defRPr sz="850" b="1">
-                <a:solidFill>
-                  <a:srgbClr val="94A3B8"/>
-                </a:solidFill>
-                <a:latin typeface="Calibri"/>
-              </a:defRPr>
-            </a:pPr>
-            <a:r>
-              <a:t>SMART INDIA HACKATHON 2026 | PS ID: SIH26082 | MoES | TEAM ATOMX: VAYUCOUPLER</a:t>
-            </a:r>
-          </a:p>
-          <a:p>
-            <a:pPr algn="r">
-              <a:defRPr sz="850">
-                <a:solidFill>
-                  <a:srgbClr val="00E5FF"/>
-                </a:solidFill>
-                <a:latin typeface="Calibri"/>
-              </a:defRPr>
-            </a:pPr>
-            <a:r>
-              <a:t>Page 5 of 6  •  Production: https://vayucoupler.vercel.app  •  GitHub: vivek-glitch15/VayuCoupler</a:t>
-            </a:r>
-          </a:p>
-        </p:txBody>
-      </p:sp>
-    </p:spTree>
-  </p:cSld>
-  <p:clrMapOvr>
-    <a:masterClrMapping/>
-  </p:clrMapOvr>
-</p:sld>
-</file>
-
-<file path=ppt/slides/slide6.xml><?xml version="1.0" encoding="utf-8"?>
-<p:sld xmlns:a="http://schemas.openxmlformats.org/drawingml/2006/main" xmlns:p="http://schemas.openxmlformats.org/presentationml/2006/main" xmlns:r="http://schemas.openxmlformats.org/officeDocument/2006/relationships">
-  <p:cSld>
-    <p:bg>
-      <p:bgPr>
-        <a:solidFill>
-          <a:srgbClr val="0A1128"/>
-        </a:solidFill>
-        <a:effectLst/>
-      </p:bgPr>
-    </p:bg>
-    <p:spTree>
-      <p:nvGrpSpPr>
-        <p:cNvPr id="1" name=""/>
-        <p:cNvGrpSpPr/>
-        <p:nvPr/>
-      </p:nvGrpSpPr>
-      <p:grpSpPr/>
-      <p:sp>
-        <p:nvSpPr>
-          <p:cNvPr id="2" name="TextBox 1"/>
-          <p:cNvSpPr txBox="1"/>
-          <p:nvPr/>
-        </p:nvSpPr>
-        <p:spPr>
-          <a:xfrm>
-            <a:off x="731520" y="365760"/>
-            <a:ext cx="10698480" cy="274320"/>
-          </a:xfrm>
-          <a:prstGeom prst="rect">
-            <a:avLst/>
-          </a:prstGeom>
-          <a:noFill/>
-        </p:spPr>
-        <p:txBody>
-          <a:bodyPr wrap="square" lIns="0" tIns="0" rIns="0" bIns="0">
-            <a:spAutoFit/>
-          </a:bodyPr>
-          <a:lstStyle/>
-          <a:p>
-            <a:pPr>
-              <a:defRPr sz="950" b="1">
-                <a:solidFill>
-                  <a:srgbClr val="00E5FF"/>
-                </a:solidFill>
-                <a:latin typeface="Calibri"/>
-              </a:defRPr>
-            </a:pPr>
-            <a:r>
-              <a:t>SIH26082 | IMPACT, ROADMAP &amp; LIVE DEMONSTRATION PLAN</a:t>
-            </a:r>
-          </a:p>
-        </p:txBody>
-      </p:sp>
-      <p:sp>
-        <p:nvSpPr>
-          <p:cNvPr id="3" name="TextBox 2"/>
-          <p:cNvSpPr txBox="1"/>
-          <p:nvPr/>
-        </p:nvSpPr>
-        <p:spPr>
-          <a:xfrm>
-            <a:off x="731520" y="621792"/>
-            <a:ext cx="10698480" cy="502920"/>
-          </a:xfrm>
-          <a:prstGeom prst="rect">
-            <a:avLst/>
-          </a:prstGeom>
-          <a:noFill/>
-        </p:spPr>
-        <p:txBody>
-          <a:bodyPr wrap="square" lIns="0" tIns="0" rIns="0" bIns="0">
-            <a:spAutoFit/>
-          </a:bodyPr>
-          <a:lstStyle/>
-          <a:p>
-            <a:pPr>
-              <a:defRPr sz="2100" b="1">
-                <a:solidFill>
-                  <a:srgbClr val="FFFFFF"/>
-                </a:solidFill>
-                <a:latin typeface="Calibri"/>
-              </a:defRPr>
-            </a:pPr>
-            <a:r>
-              <a:t>Measurable Impact, National Roadmap &amp; 3-Minute Demo Workflow</a:t>
-            </a:r>
-          </a:p>
-        </p:txBody>
-      </p:sp>
-      <p:sp>
-        <p:nvSpPr>
-          <p:cNvPr id="4" name="TextBox 3"/>
-          <p:cNvSpPr txBox="1"/>
-          <p:nvPr/>
-        </p:nvSpPr>
-        <p:spPr>
-          <a:xfrm>
-            <a:off x="731520" y="1124712"/>
-            <a:ext cx="10698480" cy="274320"/>
-          </a:xfrm>
-          <a:prstGeom prst="rect">
-            <a:avLst/>
-          </a:prstGeom>
-          <a:noFill/>
-        </p:spPr>
-        <p:txBody>
-          <a:bodyPr wrap="square" lIns="0" tIns="0" rIns="0" bIns="0">
-            <a:spAutoFit/>
-          </a:bodyPr>
-          <a:lstStyle/>
-          <a:p>
-            <a:pPr>
-              <a:defRPr sz="1150">
-                <a:solidFill>
-                  <a:srgbClr val="94A3B8"/>
-                </a:solidFill>
-                <a:latin typeface="Calibri"/>
-              </a:defRPr>
-            </a:pPr>
-            <a:r>
-              <a:t>Delivering India's first operational Weather–Pollution Coupled Predictive GRAP System.</a:t>
-            </a:r>
-          </a:p>
-        </p:txBody>
-      </p:sp>
-      <p:sp>
-        <p:nvSpPr>
-          <p:cNvPr id="5" name="Rounded Rectangle 4"/>
+              <a:defRPr sz="880">
+                <a:solidFill>
+                  <a:srgbClr val="EEF0EC"/>
+                </a:solidFill>
+              </a:defRPr>
+            </a:pPr>
+            <a:r>
+              <a:t>• Open-Source GitHub Repository: Complete verified codebase at github.com/vivek-glitch15/VayuCoupler.</a:t>
+            </a:r>
+          </a:p>
+        </p:txBody>
+      </p:sp>
+      <p:sp>
+        <p:nvSpPr>
+          <p:cNvPr id="9" name="Rounded Rectangle 8"/>
           <p:cNvSpPr/>
           <p:nvPr/>
         </p:nvSpPr>
         <p:spPr>
           <a:xfrm>
-            <a:off x="731520" y="1508760"/>
-            <a:ext cx="3328416" cy="1371600"/>
+            <a:off x="6229807" y="3730752"/>
+            <a:ext cx="5230368" cy="2468880"/>
           </a:xfrm>
           <a:prstGeom prst="roundRect">
             <a:avLst/>
           </a:prstGeom>
           <a:solidFill>
-            <a:srgbClr val="0F172A"/>
+            <a:srgbClr val="191C19"/>
           </a:solidFill>
           <a:ln w="15240">
             <a:solidFill>
@@ -6648,14 +6498,14 @@
       </p:sp>
       <p:sp>
         <p:nvSpPr>
-          <p:cNvPr id="6" name="TextBox 5"/>
+          <p:cNvPr id="10" name="TextBox 9"/>
           <p:cNvSpPr txBox="1"/>
           <p:nvPr/>
         </p:nvSpPr>
         <p:spPr>
           <a:xfrm>
-            <a:off x="841248" y="1572768"/>
-            <a:ext cx="3108960" cy="1234440"/>
+            <a:off x="6366967" y="3822191"/>
+            <a:ext cx="4956048" cy="2286000"/>
           </a:xfrm>
           <a:prstGeom prst="rect">
             <a:avLst/>
@@ -6669,97 +6519,103 @@
           <a:lstStyle/>
           <a:p>
             <a:pPr>
-              <a:defRPr b="1" sz="1800">
+              <a:defRPr b="1" sz="1100">
                 <a:solidFill>
                   <a:srgbClr val="00E5FF"/>
                 </a:solidFill>
               </a:defRPr>
             </a:pPr>
             <a:r>
-              <a:t>48 to 72 HOURS</a:t>
-            </a:r>
-          </a:p>
-          <a:p>
-            <a:pPr>
-              <a:defRPr b="1" sz="950">
-                <a:solidFill>
-                  <a:srgbClr val="FFFFFF"/>
-                </a:solidFill>
-              </a:defRPr>
-            </a:pPr>
-            <a:r>
-              <a:t>ADVANCE ACTION LEAD TIME</a:t>
-            </a:r>
-          </a:p>
-          <a:p>
-            <a:pPr>
-              <a:defRPr sz="819">
-                <a:solidFill>
-                  <a:srgbClr val="E2E8F0"/>
-                </a:solidFill>
-              </a:defRPr>
-            </a:pPr>
-            <a:r>
-              <a:t>Replaces sudden same-day school closures and emergency bans with structured 3-day readiness.</a:t>
-            </a:r>
-          </a:p>
-        </p:txBody>
-      </p:sp>
-      <p:sp>
-        <p:nvSpPr>
-          <p:cNvPr id="7" name="Rounded Rectangle 6"/>
-          <p:cNvSpPr/>
-          <p:nvPr/>
-        </p:nvSpPr>
-        <p:spPr>
-          <a:xfrm>
-            <a:off x="4425696" y="1508760"/>
-            <a:ext cx="3328416" cy="1371600"/>
-          </a:xfrm>
-          <a:prstGeom prst="roundRect">
-            <a:avLst/>
-          </a:prstGeom>
-          <a:solidFill>
-            <a:srgbClr val="0F172A"/>
-          </a:solidFill>
-          <a:ln w="15240">
-            <a:solidFill>
-              <a:srgbClr val="10B981"/>
-            </a:solidFill>
-          </a:ln>
-        </p:spPr>
-        <p:style>
-          <a:lnRef idx="1">
-            <a:schemeClr val="accent1"/>
-          </a:lnRef>
-          <a:fillRef idx="3">
-            <a:schemeClr val="accent1"/>
-          </a:fillRef>
-          <a:effectRef idx="2">
-            <a:schemeClr val="accent1"/>
-          </a:effectRef>
-          <a:fontRef idx="minor">
-            <a:schemeClr val="lt1"/>
-          </a:fontRef>
-        </p:style>
-        <p:txBody>
-          <a:bodyPr rtlCol="0" anchor="ctr"/>
-          <a:lstStyle/>
-          <a:p>
-            <a:pPr algn="ctr"/>
-          </a:p>
-        </p:txBody>
-      </p:sp>
-      <p:sp>
-        <p:nvSpPr>
-          <p:cNvPr id="8" name="TextBox 7"/>
+              <a:t>⏱️ 3-MINUTE HACKATHON JURY DEMONSTRATION SCRIPT</a:t>
+            </a:r>
+          </a:p>
+          <a:p>
+            <a:pPr>
+              <a:spcBef>
+                <a:spcPts val="200"/>
+              </a:spcBef>
+              <a:defRPr sz="840">
+                <a:solidFill>
+                  <a:srgbClr val="EEF0EC"/>
+                </a:solidFill>
+              </a:defRPr>
+            </a:pPr>
+            <a:r>
+              <a:t>0:00 - 0:45 | Home Cockpit: Open app. Showcase Ambient Halo AQI meter (157), switch station to Punjabi Bagh, inspect category badge and 3-Day Forecast strip.</a:t>
+            </a:r>
+          </a:p>
+          <a:p>
+            <a:pPr>
+              <a:spcBef>
+                <a:spcPts val="200"/>
+              </a:spcBef>
+              <a:defRPr sz="840">
+                <a:solidFill>
+                  <a:srgbClr val="EEF0EC"/>
+                </a:solidFill>
+              </a:defRPr>
+            </a:pPr>
+            <a:r>
+              <a:t>0:45 - 1:30 | Weather Engine: Tap Weather tab. Demonstrate °C/°F toggle, 4 microclimate cards (Rain %, Wind, Humidity %, UV), 8-day outlook and hourly scrubber.</a:t>
+            </a:r>
+          </a:p>
+          <a:p>
+            <a:pPr>
+              <a:spcBef>
+                <a:spcPts val="200"/>
+              </a:spcBef>
+              <a:defRPr sz="840">
+                <a:solidFill>
+                  <a:srgbClr val="EEF0EC"/>
+                </a:solidFill>
+              </a:defRPr>
+            </a:pPr>
+            <a:r>
+              <a:t>1:30 - 2:15 | Map &amp; Safe Commute: Tap Map to inspect 40+ Delhi-NCR stations. Switch to Commute tab: show Cleanest vs Fastest route saving 42% inhaled PM2.5!</a:t>
+            </a:r>
+          </a:p>
+          <a:p>
+            <a:pPr>
+              <a:spcBef>
+                <a:spcPts val="200"/>
+              </a:spcBef>
+              <a:defRPr sz="840">
+                <a:solidFill>
+                  <a:srgbClr val="EEF0EC"/>
+                </a:solidFill>
+              </a:defRPr>
+            </a:pPr>
+            <a:r>
+              <a:t>2:15 - 3:00 | VayuAI Assistant: Tap VayuAI tab. Click 'Is it safe for morning jog?' and show instant grounded response. Open for Jury Q&amp;A!</a:t>
+            </a:r>
+          </a:p>
+          <a:p>
+            <a:pPr>
+              <a:spcBef>
+                <a:spcPts val="400"/>
+              </a:spcBef>
+              <a:defRPr b="1" sz="919">
+                <a:solidFill>
+                  <a:srgbClr val="8FFFB0"/>
+                </a:solidFill>
+              </a:defRPr>
+            </a:pPr>
+            <a:r>
+              <a:t>Team AtomX thanks the Jury! Live Web: https://vayucoupler.vercel.app</a:t>
+            </a:r>
+          </a:p>
+        </p:txBody>
+      </p:sp>
+      <p:sp>
+        <p:nvSpPr>
+          <p:cNvPr id="11" name="TextBox 10"/>
           <p:cNvSpPr txBox="1"/>
           <p:nvPr/>
         </p:nvSpPr>
         <p:spPr>
           <a:xfrm>
-            <a:off x="4535424" y="1572768"/>
-            <a:ext cx="3108960" cy="1234440"/>
+            <a:off x="731520" y="6327648"/>
+            <a:ext cx="10698480" cy="274320"/>
           </a:xfrm>
           <a:prstGeom prst="rect">
             <a:avLst/>
@@ -6767,485 +6623,6 @@
           <a:noFill/>
         </p:spPr>
         <p:txBody>
-          <a:bodyPr wrap="square">
-            <a:spAutoFit/>
-          </a:bodyPr>
-          <a:lstStyle/>
-          <a:p>
-            <a:pPr>
-              <a:defRPr b="1" sz="1800">
-                <a:solidFill>
-                  <a:srgbClr val="10B981"/>
-                </a:solidFill>
-              </a:defRPr>
-            </a:pPr>
-            <a:r>
-              <a:t>25% – 35% REDUCTION</a:t>
-            </a:r>
-          </a:p>
-          <a:p>
-            <a:pPr>
-              <a:defRPr b="1" sz="950">
-                <a:solidFill>
-                  <a:srgbClr val="FFFFFF"/>
-                </a:solidFill>
-              </a:defRPr>
-            </a:pPr>
-            <a:r>
-              <a:t>PEAK RESPIRATORY HOSPITALIZATIONS</a:t>
-            </a:r>
-          </a:p>
-          <a:p>
-            <a:pPr>
-              <a:defRPr sz="819">
-                <a:solidFill>
-                  <a:srgbClr val="E2E8F0"/>
-                </a:solidFill>
-              </a:defRPr>
-            </a:pPr>
-            <a:r>
-              <a:t>Pre-empting extreme PM2.5 spikes (450+) protects vulnerable children, senior citizens, and asthma patients.</a:t>
-            </a:r>
-          </a:p>
-        </p:txBody>
-      </p:sp>
-      <p:sp>
-        <p:nvSpPr>
-          <p:cNvPr id="9" name="Rounded Rectangle 8"/>
-          <p:cNvSpPr/>
-          <p:nvPr/>
-        </p:nvSpPr>
-        <p:spPr>
-          <a:xfrm>
-            <a:off x="8119872" y="1508760"/>
-            <a:ext cx="3328416" cy="1371600"/>
-          </a:xfrm>
-          <a:prstGeom prst="roundRect">
-            <a:avLst/>
-          </a:prstGeom>
-          <a:solidFill>
-            <a:srgbClr val="0F172A"/>
-          </a:solidFill>
-          <a:ln w="15240">
-            <a:solidFill>
-              <a:srgbClr val="F59E0B"/>
-            </a:solidFill>
-          </a:ln>
-        </p:spPr>
-        <p:style>
-          <a:lnRef idx="1">
-            <a:schemeClr val="accent1"/>
-          </a:lnRef>
-          <a:fillRef idx="3">
-            <a:schemeClr val="accent1"/>
-          </a:fillRef>
-          <a:effectRef idx="2">
-            <a:schemeClr val="accent1"/>
-          </a:effectRef>
-          <a:fontRef idx="minor">
-            <a:schemeClr val="lt1"/>
-          </a:fontRef>
-        </p:style>
-        <p:txBody>
-          <a:bodyPr rtlCol="0" anchor="ctr"/>
-          <a:lstStyle/>
-          <a:p>
-            <a:pPr algn="ctr"/>
-          </a:p>
-        </p:txBody>
-      </p:sp>
-      <p:sp>
-        <p:nvSpPr>
-          <p:cNvPr id="10" name="TextBox 9"/>
-          <p:cNvSpPr txBox="1"/>
-          <p:nvPr/>
-        </p:nvSpPr>
-        <p:spPr>
-          <a:xfrm>
-            <a:off x="8229600" y="1572768"/>
-            <a:ext cx="3108960" cy="1234440"/>
-          </a:xfrm>
-          <a:prstGeom prst="rect">
-            <a:avLst/>
-          </a:prstGeom>
-          <a:noFill/>
-        </p:spPr>
-        <p:txBody>
-          <a:bodyPr wrap="square">
-            <a:spAutoFit/>
-          </a:bodyPr>
-          <a:lstStyle/>
-          <a:p>
-            <a:pPr>
-              <a:defRPr b="1" sz="1800">
-                <a:solidFill>
-                  <a:srgbClr val="F59E0B"/>
-                </a:solidFill>
-              </a:defRPr>
-            </a:pPr>
-            <a:r>
-              <a:t>₹1,200+ CRORE</a:t>
-            </a:r>
-          </a:p>
-          <a:p>
-            <a:pPr>
-              <a:defRPr b="1" sz="950">
-                <a:solidFill>
-                  <a:srgbClr val="FFFFFF"/>
-                </a:solidFill>
-              </a:defRPr>
-            </a:pPr>
-            <a:r>
-              <a:t>ESTIMATED AVOIDED ECONOMIC LOSS</a:t>
-            </a:r>
-          </a:p>
-          <a:p>
-            <a:pPr>
-              <a:defRPr sz="819">
-                <a:solidFill>
-                  <a:srgbClr val="E2E8F0"/>
-                </a:solidFill>
-              </a:defRPr>
-            </a:pPr>
-            <a:r>
-              <a:t>Prevents chaotic blanket factory shutdowns and stranded interstate freight fleets through managed pre-routing.</a:t>
-            </a:r>
-          </a:p>
-        </p:txBody>
-      </p:sp>
-      <p:sp>
-        <p:nvSpPr>
-          <p:cNvPr id="11" name="Rounded Rectangle 10"/>
-          <p:cNvSpPr/>
-          <p:nvPr/>
-        </p:nvSpPr>
-        <p:spPr>
-          <a:xfrm>
-            <a:off x="731520" y="3017520"/>
-            <a:ext cx="5166360" cy="3154680"/>
-          </a:xfrm>
-          <a:prstGeom prst="roundRect">
-            <a:avLst/>
-          </a:prstGeom>
-          <a:solidFill>
-            <a:srgbClr val="131D3A"/>
-          </a:solidFill>
-          <a:ln w="15240">
-            <a:solidFill>
-              <a:srgbClr val="26385F"/>
-            </a:solidFill>
-          </a:ln>
-        </p:spPr>
-        <p:style>
-          <a:lnRef idx="1">
-            <a:schemeClr val="accent1"/>
-          </a:lnRef>
-          <a:fillRef idx="3">
-            <a:schemeClr val="accent1"/>
-          </a:fillRef>
-          <a:effectRef idx="2">
-            <a:schemeClr val="accent1"/>
-          </a:effectRef>
-          <a:fontRef idx="minor">
-            <a:schemeClr val="lt1"/>
-          </a:fontRef>
-        </p:style>
-        <p:txBody>
-          <a:bodyPr rtlCol="0" anchor="ctr"/>
-          <a:lstStyle/>
-          <a:p>
-            <a:pPr algn="ctr"/>
-          </a:p>
-        </p:txBody>
-      </p:sp>
-      <p:sp>
-        <p:nvSpPr>
-          <p:cNvPr id="12" name="TextBox 11"/>
-          <p:cNvSpPr txBox="1"/>
-          <p:nvPr/>
-        </p:nvSpPr>
-        <p:spPr>
-          <a:xfrm>
-            <a:off x="868680" y="3108960"/>
-            <a:ext cx="4892040" cy="2971800"/>
-          </a:xfrm>
-          <a:prstGeom prst="rect">
-            <a:avLst/>
-          </a:prstGeom>
-          <a:noFill/>
-        </p:spPr>
-        <p:txBody>
-          <a:bodyPr wrap="square">
-            <a:spAutoFit/>
-          </a:bodyPr>
-          <a:lstStyle/>
-          <a:p>
-            <a:pPr>
-              <a:defRPr b="1" sz="1100">
-                <a:solidFill>
-                  <a:srgbClr val="00E5FF"/>
-                </a:solidFill>
-              </a:defRPr>
-            </a:pPr>
-            <a:r>
-              <a:t>🏛️ SCALABILITY &amp; MOES ADOPTION ROADMAP</a:t>
-            </a:r>
-          </a:p>
-          <a:p>
-            <a:pPr>
-              <a:spcBef>
-                <a:spcPts val="400"/>
-              </a:spcBef>
-              <a:defRPr b="1" sz="880">
-                <a:solidFill>
-                  <a:srgbClr val="F59E0B"/>
-                </a:solidFill>
-              </a:defRPr>
-            </a:pPr>
-            <a:r>
-              <a:t>Phase 1 (M 1–3) | Delhi NCR CAQM Pilot:</a:t>
-            </a:r>
-          </a:p>
-          <a:p>
-            <a:pPr>
-              <a:defRPr sz="840">
-                <a:solidFill>
-                  <a:srgbClr val="E2E8F0"/>
-                </a:solidFill>
-              </a:defRPr>
-            </a:pPr>
-            <a:r>
-              <a:t>Ingestion from all 40 CPCB CAAQMS stations + daily automated predictive GRAP briefings dispatched to Commission members.</a:t>
-            </a:r>
-          </a:p>
-          <a:p>
-            <a:pPr>
-              <a:spcBef>
-                <a:spcPts val="400"/>
-              </a:spcBef>
-              <a:defRPr b="1" sz="880">
-                <a:solidFill>
-                  <a:srgbClr val="F59E0B"/>
-                </a:solidFill>
-              </a:defRPr>
-            </a:pPr>
-            <a:r>
-              <a:t>Phase 2 (M 4–8) | Indo-Gangetic Basin:</a:t>
-            </a:r>
-          </a:p>
-          <a:p>
-            <a:pPr>
-              <a:defRPr sz="840">
-                <a:solidFill>
-                  <a:srgbClr val="E2E8F0"/>
-                </a:solidFill>
-              </a:defRPr>
-            </a:pPr>
-            <a:r>
-              <a:t>Scaling models to Kanpur, Lucknow, Patna &amp; Kolkata air-sheds + INSAT-3D AOD &amp; Sentinel-5P TROPOMI satellite telemetry.</a:t>
-            </a:r>
-          </a:p>
-          <a:p>
-            <a:pPr>
-              <a:spcBef>
-                <a:spcPts val="400"/>
-              </a:spcBef>
-              <a:defRPr b="1" sz="880">
-                <a:solidFill>
-                  <a:srgbClr val="F59E0B"/>
-                </a:solidFill>
-              </a:defRPr>
-            </a:pPr>
-            <a:r>
-              <a:t>Phase 3 (M 9–12) | Nationwide NCAP Integration:</a:t>
-            </a:r>
-          </a:p>
-          <a:p>
-            <a:pPr>
-              <a:defRPr sz="840">
-                <a:solidFill>
-                  <a:srgbClr val="E2E8F0"/>
-                </a:solidFill>
-              </a:defRPr>
-            </a:pPr>
-            <a:r>
-              <a:t>Direct coupling with IMD's 3km Eulerian WRF-Chem atmospheric models and CEMS at 1,000+ industrial smokestacks. Zero license lock-in.</a:t>
-            </a:r>
-          </a:p>
-        </p:txBody>
-      </p:sp>
-      <p:sp>
-        <p:nvSpPr>
-          <p:cNvPr id="13" name="Rounded Rectangle 12"/>
-          <p:cNvSpPr/>
-          <p:nvPr/>
-        </p:nvSpPr>
-        <p:spPr>
-          <a:xfrm>
-            <a:off x="6291072" y="3017520"/>
-            <a:ext cx="5166360" cy="3154680"/>
-          </a:xfrm>
-          <a:prstGeom prst="roundRect">
-            <a:avLst/>
-          </a:prstGeom>
-          <a:solidFill>
-            <a:srgbClr val="131D3A"/>
-          </a:solidFill>
-          <a:ln w="15240">
-            <a:solidFill>
-              <a:srgbClr val="10B981"/>
-            </a:solidFill>
-          </a:ln>
-        </p:spPr>
-        <p:style>
-          <a:lnRef idx="1">
-            <a:schemeClr val="accent1"/>
-          </a:lnRef>
-          <a:fillRef idx="3">
-            <a:schemeClr val="accent1"/>
-          </a:fillRef>
-          <a:effectRef idx="2">
-            <a:schemeClr val="accent1"/>
-          </a:effectRef>
-          <a:fontRef idx="minor">
-            <a:schemeClr val="lt1"/>
-          </a:fontRef>
-        </p:style>
-        <p:txBody>
-          <a:bodyPr rtlCol="0" anchor="ctr"/>
-          <a:lstStyle/>
-          <a:p>
-            <a:pPr algn="ctr"/>
-          </a:p>
-        </p:txBody>
-      </p:sp>
-      <p:sp>
-        <p:nvSpPr>
-          <p:cNvPr id="14" name="TextBox 13"/>
-          <p:cNvSpPr txBox="1"/>
-          <p:nvPr/>
-        </p:nvSpPr>
-        <p:spPr>
-          <a:xfrm>
-            <a:off x="6428232" y="3108960"/>
-            <a:ext cx="4892040" cy="2971800"/>
-          </a:xfrm>
-          <a:prstGeom prst="rect">
-            <a:avLst/>
-          </a:prstGeom>
-          <a:noFill/>
-        </p:spPr>
-        <p:txBody>
-          <a:bodyPr wrap="square">
-            <a:spAutoFit/>
-          </a:bodyPr>
-          <a:lstStyle/>
-          <a:p>
-            <a:pPr>
-              <a:defRPr b="1" sz="1100">
-                <a:solidFill>
-                  <a:srgbClr val="10B981"/>
-                </a:solidFill>
-              </a:defRPr>
-            </a:pPr>
-            <a:r>
-              <a:t>⏱️ 3-MINUTE JUDGE DEMO SCRIPT &amp; LIVE ARTIFACTS</a:t>
-            </a:r>
-          </a:p>
-          <a:p>
-            <a:pPr>
-              <a:spcBef>
-                <a:spcPts val="300"/>
-              </a:spcBef>
-              <a:defRPr sz="840">
-                <a:solidFill>
-                  <a:srgbClr val="E2E8F0"/>
-                </a:solidFill>
-              </a:defRPr>
-            </a:pPr>
-            <a:r>
-              <a:t>0:00 - 0:45 | 30s Pitch: Open https://vayucoupler.vercel.app. Pitch: 'Current GRAP is reactive; VayuCoupler predicts spikes 48h early via meteorology coupling.'</a:t>
-            </a:r>
-          </a:p>
-          <a:p>
-            <a:pPr>
-              <a:spcBef>
-                <a:spcPts val="300"/>
-              </a:spcBef>
-              <a:defRPr sz="840">
-                <a:solidFill>
-                  <a:srgbClr val="E2E8F0"/>
-                </a:solidFill>
-              </a:defRPr>
-            </a:pPr>
-            <a:r>
-              <a:t>0:45 - 1:30 | 7-Day Scrubber: Scrub to T-72h. Show monitored AQI is still Moderate (~210), but boundary layer collapses to 340m, forecasting 480+ for T+48h.</a:t>
-            </a:r>
-          </a:p>
-          <a:p>
-            <a:pPr>
-              <a:spcBef>
-                <a:spcPts val="300"/>
-              </a:spcBef>
-              <a:defRPr sz="840">
-                <a:solidFill>
-                  <a:srgbClr val="E2E8F0"/>
-                </a:solidFill>
-              </a:defRPr>
-            </a:pPr>
-            <a:r>
-              <a:t>1:30 - 2:15 | Predictive GRAP: Show Stage III/IV in 'PRE-EMPTIVE TRIGGER' state. Inspect automated dispatch payloads for Punjab Agri &amp; Delhi Police.</a:t>
-            </a:r>
-          </a:p>
-          <a:p>
-            <a:pPr>
-              <a:spcBef>
-                <a:spcPts val="300"/>
-              </a:spcBef>
-              <a:defRPr sz="840">
-                <a:solidFill>
-                  <a:srgbClr val="E2E8F0"/>
-                </a:solidFill>
-              </a:defRPr>
-            </a:pPr>
-            <a:r>
-              <a:t>2:15 - 3:00 | 'What-If' Testing: Move Stubble Reduction to 50% and Truck Diversion to 40%. Watch peak AQI drop from 485 to 382. Ready for Jury Q&amp;A!</a:t>
-            </a:r>
-          </a:p>
-          <a:p>
-            <a:pPr>
-              <a:spcBef>
-                <a:spcPts val="600"/>
-              </a:spcBef>
-              <a:defRPr b="1" sz="950">
-                <a:solidFill>
-                  <a:srgbClr val="00E5FF"/>
-                </a:solidFill>
-              </a:defRPr>
-            </a:pPr>
-            <a:r>
-              <a:t>Team AtomX thanks the Jury! Live Web: https://vayucoupler.vercel.app</a:t>
-            </a:r>
-          </a:p>
-        </p:txBody>
-      </p:sp>
-      <p:sp>
-        <p:nvSpPr>
-          <p:cNvPr id="15" name="TextBox 14"/>
-          <p:cNvSpPr txBox="1"/>
-          <p:nvPr/>
-        </p:nvSpPr>
-        <p:spPr>
-          <a:xfrm>
-            <a:off x="731520" y="6327648"/>
-            <a:ext cx="10698480" cy="274320"/>
-          </a:xfrm>
-          <a:prstGeom prst="rect">
-            <a:avLst/>
-          </a:prstGeom>
-          <a:noFill/>
-        </p:spPr>
-        <p:txBody>
           <a:bodyPr wrap="square" lIns="0" tIns="0" rIns="0" bIns="0">
             <a:spAutoFit/>
           </a:bodyPr>
@@ -7254,7 +6631,7 @@
             <a:pPr>
               <a:defRPr sz="850" b="1">
                 <a:solidFill>
-                  <a:srgbClr val="94A3B8"/>
+                  <a:srgbClr val="8C948B"/>
                 </a:solidFill>
                 <a:latin typeface="Calibri"/>
               </a:defRPr>
@@ -7267,7 +6644,7 @@
             <a:pPr algn="r">
               <a:defRPr sz="850">
                 <a:solidFill>
-                  <a:srgbClr val="00E5FF"/>
+                  <a:srgbClr val="8FFFB0"/>
                 </a:solidFill>
                 <a:latin typeface="Calibri"/>
               </a:defRPr>

</xml_diff>